<commit_message>
Adding slides I've made
</commit_message>
<xml_diff>
--- a/slides/Forecasting Volatility In Stock Market.pptx
+++ b/slides/Forecasting Volatility In Stock Market.pptx
@@ -26,9 +26,9 @@
     <p:sldId id="273" r:id="rId17"/>
     <p:sldId id="277" r:id="rId18"/>
     <p:sldId id="274" r:id="rId19"/>
-    <p:sldId id="278" r:id="rId20"/>
-    <p:sldId id="275" r:id="rId21"/>
-    <p:sldId id="279" r:id="rId22"/>
+    <p:sldId id="283" r:id="rId20"/>
+    <p:sldId id="282" r:id="rId21"/>
+    <p:sldId id="284" r:id="rId22"/>
     <p:sldId id="280" r:id="rId23"/>
     <p:sldId id="276" r:id="rId24"/>
   </p:sldIdLst>
@@ -1799,7 +1799,7 @@
         <p:cNvPr id="1" name="">
           <a:extLst>
             <a:ext uri="{FF2B5EF4-FFF2-40B4-BE49-F238E27FC236}">
-              <a16:creationId xmlns:a16="http://schemas.microsoft.com/office/drawing/2014/main" id="{9DE60C88-F203-C61E-434A-DAF6EE8B1043}"/>
+              <a16:creationId xmlns:a16="http://schemas.microsoft.com/office/drawing/2014/main" id="{100E7940-1922-2022-691F-C2482E770F8B}"/>
             </a:ext>
           </a:extLst>
         </p:cNvPr>
@@ -1819,7 +1819,7 @@
           <p:cNvPr id="237" name="PlaceHolder 1">
             <a:extLst>
               <a:ext uri="{FF2B5EF4-FFF2-40B4-BE49-F238E27FC236}">
-                <a16:creationId xmlns:a16="http://schemas.microsoft.com/office/drawing/2014/main" id="{0793056F-C67F-FB88-4B89-363B348E4008}"/>
+                <a16:creationId xmlns:a16="http://schemas.microsoft.com/office/drawing/2014/main" id="{3C912DF0-6A47-97B8-532A-E80CDDC262BE}"/>
               </a:ext>
             </a:extLst>
           </p:cNvPr>
@@ -1855,7 +1855,7 @@
           <p:cNvPr id="238" name="PlaceHolder 2">
             <a:extLst>
               <a:ext uri="{FF2B5EF4-FFF2-40B4-BE49-F238E27FC236}">
-                <a16:creationId xmlns:a16="http://schemas.microsoft.com/office/drawing/2014/main" id="{5E423722-121B-5E07-6409-A6478965AC66}"/>
+                <a16:creationId xmlns:a16="http://schemas.microsoft.com/office/drawing/2014/main" id="{637E75FC-61CD-E396-1446-2472E0321126}"/>
               </a:ext>
             </a:extLst>
           </p:cNvPr>
@@ -1904,7 +1904,7 @@
           <p:cNvPr id="239" name="PlaceHolder 3">
             <a:extLst>
               <a:ext uri="{FF2B5EF4-FFF2-40B4-BE49-F238E27FC236}">
-                <a16:creationId xmlns:a16="http://schemas.microsoft.com/office/drawing/2014/main" id="{91C59E53-F61C-23E0-75AF-198EDF5BD7EE}"/>
+                <a16:creationId xmlns:a16="http://schemas.microsoft.com/office/drawing/2014/main" id="{1E3C99BE-1602-D94A-CB04-B6E218AB3FBB}"/>
               </a:ext>
             </a:extLst>
           </p:cNvPr>
@@ -2021,7 +2021,7 @@
     </p:spTree>
     <p:extLst>
       <p:ext uri="{BB962C8B-B14F-4D97-AF65-F5344CB8AC3E}">
-        <p14:creationId xmlns:p14="http://schemas.microsoft.com/office/powerpoint/2010/main" val="1407649017"/>
+        <p14:creationId xmlns:p14="http://schemas.microsoft.com/office/powerpoint/2010/main" val="4248603817"/>
       </p:ext>
     </p:extLst>
   </p:cSld>
@@ -2039,7 +2039,7 @@
         <p:cNvPr id="1" name="">
           <a:extLst>
             <a:ext uri="{FF2B5EF4-FFF2-40B4-BE49-F238E27FC236}">
-              <a16:creationId xmlns:a16="http://schemas.microsoft.com/office/drawing/2014/main" id="{FD33A3AC-4D4E-2472-3B3D-30D40C866DC3}"/>
+              <a16:creationId xmlns:a16="http://schemas.microsoft.com/office/drawing/2014/main" id="{B864F8E7-4A5A-B293-E545-D97C3D1523D7}"/>
             </a:ext>
           </a:extLst>
         </p:cNvPr>
@@ -2056,10 +2056,10 @@
       </p:grpSpPr>
       <p:sp>
         <p:nvSpPr>
-          <p:cNvPr id="204" name="PlaceHolder 1">
+          <p:cNvPr id="237" name="PlaceHolder 1">
             <a:extLst>
               <a:ext uri="{FF2B5EF4-FFF2-40B4-BE49-F238E27FC236}">
-                <a16:creationId xmlns:a16="http://schemas.microsoft.com/office/drawing/2014/main" id="{4B5500B3-A4FB-9680-E8F1-D87C95F85559}"/>
+                <a16:creationId xmlns:a16="http://schemas.microsoft.com/office/drawing/2014/main" id="{CC4C3637-C2C5-7BDE-9041-E2252E695EB4}"/>
               </a:ext>
             </a:extLst>
           </p:cNvPr>
@@ -2092,10 +2092,10 @@
       </p:sp>
       <p:sp>
         <p:nvSpPr>
-          <p:cNvPr id="205" name="PlaceHolder 2">
+          <p:cNvPr id="238" name="PlaceHolder 2">
             <a:extLst>
               <a:ext uri="{FF2B5EF4-FFF2-40B4-BE49-F238E27FC236}">
-                <a16:creationId xmlns:a16="http://schemas.microsoft.com/office/drawing/2014/main" id="{13B66C58-190E-1FA4-9B49-BB5423AA65FB}"/>
+                <a16:creationId xmlns:a16="http://schemas.microsoft.com/office/drawing/2014/main" id="{29E6DDEF-4BB3-258C-0600-79695349BB62}"/>
               </a:ext>
             </a:extLst>
           </p:cNvPr>
@@ -2141,10 +2141,10 @@
       </p:sp>
       <p:sp>
         <p:nvSpPr>
-          <p:cNvPr id="206" name="PlaceHolder 3">
+          <p:cNvPr id="239" name="PlaceHolder 3">
             <a:extLst>
               <a:ext uri="{FF2B5EF4-FFF2-40B4-BE49-F238E27FC236}">
-                <a16:creationId xmlns:a16="http://schemas.microsoft.com/office/drawing/2014/main" id="{52783B92-A171-ADE8-1204-915299EF75B3}"/>
+                <a16:creationId xmlns:a16="http://schemas.microsoft.com/office/drawing/2014/main" id="{8AD9C1E5-475D-9E13-1D3B-7EF48FFC6291}"/>
               </a:ext>
             </a:extLst>
           </p:cNvPr>
@@ -2152,7 +2152,7 @@
             <a:spLocks noGrp="1"/>
           </p:cNvSpPr>
           <p:nvPr>
-            <p:ph type="sldNum" idx="4"/>
+            <p:ph type="sldNum" idx="15"/>
           </p:nvPr>
         </p:nvSpPr>
         <p:spPr>
@@ -2207,7 +2207,7 @@
               <a:tabLst/>
               <a:defRPr/>
             </a:pPr>
-            <a:fld id="{B38E9D2C-E2AA-4A61-811E-44DD82E65BDC}" type="slidenum">
+            <a:fld id="{8404CCE6-61FE-46B3-8996-5BF314FE3D04}" type="slidenum">
               <a:rPr kumimoji="0" lang="en-US" sz="1200" b="0" i="0" u="none" strike="noStrike" kern="1200" cap="none" spc="0" normalizeH="0" baseline="0" noProof="0">
                 <a:ln>
                   <a:noFill/>
@@ -2261,7 +2261,7 @@
     </p:spTree>
     <p:extLst>
       <p:ext uri="{BB962C8B-B14F-4D97-AF65-F5344CB8AC3E}">
-        <p14:creationId xmlns:p14="http://schemas.microsoft.com/office/powerpoint/2010/main" val="3857854115"/>
+        <p14:creationId xmlns:p14="http://schemas.microsoft.com/office/powerpoint/2010/main" val="1796451815"/>
       </p:ext>
     </p:extLst>
   </p:cSld>
@@ -2279,7 +2279,7 @@
         <p:cNvPr id="1" name="">
           <a:extLst>
             <a:ext uri="{FF2B5EF4-FFF2-40B4-BE49-F238E27FC236}">
-              <a16:creationId xmlns:a16="http://schemas.microsoft.com/office/drawing/2014/main" id="{8AFA1EA5-6FDE-6B52-8EF7-A076C844696B}"/>
+              <a16:creationId xmlns:a16="http://schemas.microsoft.com/office/drawing/2014/main" id="{08410005-D7CE-ED44-828C-F90E1659236E}"/>
             </a:ext>
           </a:extLst>
         </p:cNvPr>
@@ -2299,7 +2299,7 @@
           <p:cNvPr id="237" name="PlaceHolder 1">
             <a:extLst>
               <a:ext uri="{FF2B5EF4-FFF2-40B4-BE49-F238E27FC236}">
-                <a16:creationId xmlns:a16="http://schemas.microsoft.com/office/drawing/2014/main" id="{4205A6D1-743C-E6ED-71AA-86015EDFA96C}"/>
+                <a16:creationId xmlns:a16="http://schemas.microsoft.com/office/drawing/2014/main" id="{AD8E4CAC-7254-6EF8-6629-73463AFCA146}"/>
               </a:ext>
             </a:extLst>
           </p:cNvPr>
@@ -2335,7 +2335,7 @@
           <p:cNvPr id="238" name="PlaceHolder 2">
             <a:extLst>
               <a:ext uri="{FF2B5EF4-FFF2-40B4-BE49-F238E27FC236}">
-                <a16:creationId xmlns:a16="http://schemas.microsoft.com/office/drawing/2014/main" id="{7ECDDF50-0499-A1F7-7C06-014844DC7668}"/>
+                <a16:creationId xmlns:a16="http://schemas.microsoft.com/office/drawing/2014/main" id="{253D9250-CADC-285B-6DD5-BC21F330C7C6}"/>
               </a:ext>
             </a:extLst>
           </p:cNvPr>
@@ -2384,7 +2384,7 @@
           <p:cNvPr id="239" name="PlaceHolder 3">
             <a:extLst>
               <a:ext uri="{FF2B5EF4-FFF2-40B4-BE49-F238E27FC236}">
-                <a16:creationId xmlns:a16="http://schemas.microsoft.com/office/drawing/2014/main" id="{8F0FEECD-0966-A1E8-C01F-23DD953A46F1}"/>
+                <a16:creationId xmlns:a16="http://schemas.microsoft.com/office/drawing/2014/main" id="{C5DE9853-38BC-9BB8-CDEC-C8EC91AFAC6C}"/>
               </a:ext>
             </a:extLst>
           </p:cNvPr>
@@ -2501,7 +2501,7 @@
     </p:spTree>
     <p:extLst>
       <p:ext uri="{BB962C8B-B14F-4D97-AF65-F5344CB8AC3E}">
-        <p14:creationId xmlns:p14="http://schemas.microsoft.com/office/powerpoint/2010/main" val="1431073771"/>
+        <p14:creationId xmlns:p14="http://schemas.microsoft.com/office/powerpoint/2010/main" val="482595730"/>
       </p:ext>
     </p:extLst>
   </p:cSld>
@@ -4317,7 +4317,7 @@
           <a:p>
             <a:fld id="{5BCAD085-E8A6-8845-BD4E-CB4CCA059FC4}" type="datetimeFigureOut">
               <a:rPr lang="en-US" smtClean="0"/>
-              <a:t>4/1/2026</a:t>
+              <a:t>4/9/2026</a:t>
             </a:fld>
             <a:endParaRPr lang="en-US"/>
           </a:p>
@@ -21643,7 +21643,7 @@
                 <a:ea typeface="Calibri"/>
                 <a:cs typeface="+mn-cs"/>
               </a:rPr>
-              <a:t>Transformer – Encoder Only</a:t>
+              <a:t>Transformer</a:t>
             </a:r>
             <a:endParaRPr kumimoji="0" lang="en-US" sz="6400" b="0" i="0" u="none" strike="noStrike" kern="1200" cap="none" spc="0" normalizeH="0" baseline="0" noProof="0" dirty="0">
               <a:ln>
@@ -21866,20 +21866,12 @@
 <file path=ppt/slides/slide18.xml><?xml version="1.0" encoding="utf-8"?>
 <p:sld xmlns:a="http://schemas.openxmlformats.org/drawingml/2006/main" xmlns:r="http://schemas.openxmlformats.org/officeDocument/2006/relationships" xmlns:p="http://schemas.openxmlformats.org/presentationml/2006/main">
   <p:cSld>
-    <p:bg>
-      <p:bgPr>
-        <a:solidFill>
-          <a:srgbClr val="F5F6F8"/>
-        </a:solidFill>
-        <a:effectLst/>
-      </p:bgPr>
-    </p:bg>
     <p:spTree>
       <p:nvGrpSpPr>
         <p:cNvPr id="1" name="">
           <a:extLst>
             <a:ext uri="{FF2B5EF4-FFF2-40B4-BE49-F238E27FC236}">
-              <a16:creationId xmlns:a16="http://schemas.microsoft.com/office/drawing/2014/main" id="{4EB94F3E-30B7-93FE-E3B0-EB4C7344520E}"/>
+              <a16:creationId xmlns:a16="http://schemas.microsoft.com/office/drawing/2014/main" id="{028CD6A1-8A4F-BE7D-AF92-E471416998CD}"/>
             </a:ext>
           </a:extLst>
         </p:cNvPr>
@@ -21899,7 +21891,7 @@
           <p:cNvPr id="193" name="Shape 0">
             <a:extLst>
               <a:ext uri="{FF2B5EF4-FFF2-40B4-BE49-F238E27FC236}">
-                <a16:creationId xmlns:a16="http://schemas.microsoft.com/office/drawing/2014/main" id="{90790CE6-B0E1-86DB-FE90-CAE7CEBEA980}"/>
+                <a16:creationId xmlns:a16="http://schemas.microsoft.com/office/drawing/2014/main" id="{B45B720F-0CB6-889A-AF1D-C9E3B9686A70}"/>
               </a:ext>
             </a:extLst>
           </p:cNvPr>
@@ -21978,7 +21970,7 @@
           <p:cNvPr id="194" name="Text 1">
             <a:extLst>
               <a:ext uri="{FF2B5EF4-FFF2-40B4-BE49-F238E27FC236}">
-                <a16:creationId xmlns:a16="http://schemas.microsoft.com/office/drawing/2014/main" id="{91BCE229-81F7-9187-8F69-159E4EB72AAD}"/>
+                <a16:creationId xmlns:a16="http://schemas.microsoft.com/office/drawing/2014/main" id="{F4C35190-7AC0-738E-15B5-9B05E2CA211C}"/>
               </a:ext>
             </a:extLst>
           </p:cNvPr>
@@ -22074,7 +22066,7 @@
           <p:cNvPr id="195" name="Shape 2">
             <a:extLst>
               <a:ext uri="{FF2B5EF4-FFF2-40B4-BE49-F238E27FC236}">
-                <a16:creationId xmlns:a16="http://schemas.microsoft.com/office/drawing/2014/main" id="{F010CC11-7492-AA17-2195-B2668255EF53}"/>
+                <a16:creationId xmlns:a16="http://schemas.microsoft.com/office/drawing/2014/main" id="{6CE34A8A-0860-D4C5-11A3-01EE61AA4117}"/>
               </a:ext>
             </a:extLst>
           </p:cNvPr>
@@ -22153,7 +22145,7 @@
           <p:cNvPr id="198" name="Shape 4">
             <a:extLst>
               <a:ext uri="{FF2B5EF4-FFF2-40B4-BE49-F238E27FC236}">
-                <a16:creationId xmlns:a16="http://schemas.microsoft.com/office/drawing/2014/main" id="{36306C58-F9C7-C9F0-B2C7-4B7F2FC4D948}"/>
+                <a16:creationId xmlns:a16="http://schemas.microsoft.com/office/drawing/2014/main" id="{BFDAAC3E-5810-35AC-EFB7-399B1CA90EB2}"/>
               </a:ext>
             </a:extLst>
           </p:cNvPr>
@@ -22235,7 +22227,7 @@
           <p:cNvPr id="199" name="Text 5">
             <a:extLst>
               <a:ext uri="{FF2B5EF4-FFF2-40B4-BE49-F238E27FC236}">
-                <a16:creationId xmlns:a16="http://schemas.microsoft.com/office/drawing/2014/main" id="{E63F8986-8780-6F86-F79D-88C25131E6E2}"/>
+                <a16:creationId xmlns:a16="http://schemas.microsoft.com/office/drawing/2014/main" id="{C41E6869-40EE-C680-2B1B-AB65F9C0ED84}"/>
               </a:ext>
             </a:extLst>
           </p:cNvPr>
@@ -22293,19 +22285,12 @@
               <a:defRPr/>
             </a:pPr>
             <a:r>
-              <a:rPr kumimoji="0" lang="en-US" sz="1733" b="1" i="0" u="none" strike="noStrike" kern="1200" cap="none" spc="0" normalizeH="0" baseline="0" noProof="0" dirty="0">
-                <a:ln>
-                  <a:noFill/>
-                </a:ln>
+              <a:rPr lang="en-US" sz="1733" b="1" dirty="0">
                 <a:solidFill>
                   <a:srgbClr val="00A8CC"/>
                 </a:solidFill>
-                <a:effectLst/>
-                <a:uLnTx/>
-                <a:uFillTx/>
                 <a:latin typeface="Calibri"/>
                 <a:ea typeface="Calibri"/>
-                <a:cs typeface="+mn-cs"/>
               </a:rPr>
               <a:t>Heading</a:t>
             </a:r>
@@ -22331,7 +22316,7 @@
           <p:cNvPr id="200" name="Text 6">
             <a:extLst>
               <a:ext uri="{FF2B5EF4-FFF2-40B4-BE49-F238E27FC236}">
-                <a16:creationId xmlns:a16="http://schemas.microsoft.com/office/drawing/2014/main" id="{44CD2CE5-7E2E-E2FF-01F1-67737D96687D}"/>
+                <a16:creationId xmlns:a16="http://schemas.microsoft.com/office/drawing/2014/main" id="{BB30473B-A6AF-1643-E846-BD5A3BCE8687}"/>
               </a:ext>
             </a:extLst>
           </p:cNvPr>
@@ -22565,7 +22550,7 @@
           <p:cNvPr id="4" name="Text 3">
             <a:extLst>
               <a:ext uri="{FF2B5EF4-FFF2-40B4-BE49-F238E27FC236}">
-                <a16:creationId xmlns:a16="http://schemas.microsoft.com/office/drawing/2014/main" id="{DABD32C7-5E89-4B0E-4EA6-524E1C84C494}"/>
+                <a16:creationId xmlns:a16="http://schemas.microsoft.com/office/drawing/2014/main" id="{3072A582-6281-0A9C-EC60-33323472EBE3}"/>
               </a:ext>
             </a:extLst>
           </p:cNvPr>
@@ -22641,7 +22626,7 @@
     </p:spTree>
     <p:extLst>
       <p:ext uri="{BB962C8B-B14F-4D97-AF65-F5344CB8AC3E}">
-        <p14:creationId xmlns:p14="http://schemas.microsoft.com/office/powerpoint/2010/main" val="4102522688"/>
+        <p14:creationId xmlns:p14="http://schemas.microsoft.com/office/powerpoint/2010/main" val="1772714182"/>
       </p:ext>
     </p:extLst>
   </p:cSld>
@@ -22657,7 +22642,7 @@
     <p:bg>
       <p:bgPr>
         <a:solidFill>
-          <a:srgbClr val="0D2340"/>
+          <a:srgbClr val="F5F6F8"/>
         </a:solidFill>
         <a:effectLst/>
       </p:bgPr>
@@ -22667,7 +22652,7 @@
         <p:cNvPr id="1" name="">
           <a:extLst>
             <a:ext uri="{FF2B5EF4-FFF2-40B4-BE49-F238E27FC236}">
-              <a16:creationId xmlns:a16="http://schemas.microsoft.com/office/drawing/2014/main" id="{EAAC4A9B-9DAB-D698-1BA4-B8B039AB4496}"/>
+              <a16:creationId xmlns:a16="http://schemas.microsoft.com/office/drawing/2014/main" id="{6224B3A4-81DC-C437-9C3A-C6BE624B27F7}"/>
             </a:ext>
           </a:extLst>
         </p:cNvPr>
@@ -22684,10 +22669,56 @@
       </p:grpSpPr>
       <p:sp>
         <p:nvSpPr>
-          <p:cNvPr id="8" name="Shape 0">
+          <p:cNvPr id="29" name="Rectangle 28">
             <a:extLst>
               <a:ext uri="{FF2B5EF4-FFF2-40B4-BE49-F238E27FC236}">
-                <a16:creationId xmlns:a16="http://schemas.microsoft.com/office/drawing/2014/main" id="{EDFC5CF6-BC1B-FCB1-B955-C8CC6421B968}"/>
+                <a16:creationId xmlns:a16="http://schemas.microsoft.com/office/drawing/2014/main" id="{713B7816-D9D9-F558-8C77-50C0B70EC7B5}"/>
+              </a:ext>
+            </a:extLst>
+          </p:cNvPr>
+          <p:cNvSpPr/>
+          <p:nvPr/>
+        </p:nvSpPr>
+        <p:spPr>
+          <a:xfrm>
+            <a:off x="5576637" y="733926"/>
+            <a:ext cx="3001879" cy="5534527"/>
+          </a:xfrm>
+          <a:prstGeom prst="rect">
+            <a:avLst/>
+          </a:prstGeom>
+        </p:spPr>
+        <p:style>
+          <a:lnRef idx="2">
+            <a:schemeClr val="accent1">
+              <a:shade val="15000"/>
+            </a:schemeClr>
+          </a:lnRef>
+          <a:fillRef idx="1">
+            <a:schemeClr val="accent1"/>
+          </a:fillRef>
+          <a:effectRef idx="0">
+            <a:schemeClr val="accent1"/>
+          </a:effectRef>
+          <a:fontRef idx="minor">
+            <a:schemeClr val="lt1"/>
+          </a:fontRef>
+        </p:style>
+        <p:txBody>
+          <a:bodyPr rtlCol="0" anchor="ctr"/>
+          <a:lstStyle/>
+          <a:p>
+            <a:pPr algn="ctr"/>
+            <a:endParaRPr lang="en-US"/>
+          </a:p>
+        </p:txBody>
+      </p:sp>
+      <p:sp>
+        <p:nvSpPr>
+          <p:cNvPr id="193" name="Shape 0">
+            <a:extLst>
+              <a:ext uri="{FF2B5EF4-FFF2-40B4-BE49-F238E27FC236}">
+                <a16:creationId xmlns:a16="http://schemas.microsoft.com/office/drawing/2014/main" id="{69F5ECB5-D50B-1D08-53F8-3CF9A6121EB6}"/>
               </a:ext>
             </a:extLst>
           </p:cNvPr>
@@ -22697,13 +22728,13 @@
         <p:spPr>
           <a:xfrm>
             <a:off x="0" y="0"/>
-            <a:ext cx="145920" cy="6857760"/>
+            <a:ext cx="12191520" cy="633600"/>
           </a:xfrm>
           <a:prstGeom prst="rect">
             <a:avLst/>
           </a:prstGeom>
           <a:solidFill>
-            <a:srgbClr val="00A8CC"/>
+            <a:srgbClr val="0D2340"/>
           </a:solidFill>
           <a:ln w="0">
             <a:noFill/>
@@ -22763,10 +22794,10 @@
       </p:sp>
       <p:sp>
         <p:nvSpPr>
-          <p:cNvPr id="9" name="Text 1">
+          <p:cNvPr id="194" name="Text 1">
             <a:extLst>
               <a:ext uri="{FF2B5EF4-FFF2-40B4-BE49-F238E27FC236}">
-                <a16:creationId xmlns:a16="http://schemas.microsoft.com/office/drawing/2014/main" id="{DE0349E3-E83F-C299-563A-4231C7D3EF5B}"/>
+                <a16:creationId xmlns:a16="http://schemas.microsoft.com/office/drawing/2014/main" id="{1939BC8B-D1CC-7A00-F1A3-D8C92FCA72E7}"/>
               </a:ext>
             </a:extLst>
           </p:cNvPr>
@@ -22775,8 +22806,8 @@
         </p:nvSpPr>
         <p:spPr>
           <a:xfrm>
-            <a:off x="426720" y="975360"/>
-            <a:ext cx="11338080" cy="2100943"/>
+            <a:off x="304800" y="18083"/>
+            <a:ext cx="11581920" cy="560160"/>
           </a:xfrm>
           <a:prstGeom prst="rect">
             <a:avLst/>
@@ -22799,7 +22830,7 @@
           <a:fontRef idx="minor"/>
         </p:style>
         <p:txBody>
-          <a:bodyPr lIns="120000" tIns="60000" rIns="120000" bIns="60000" anchor="t">
+          <a:bodyPr lIns="120000" tIns="60000" rIns="120000" bIns="60000" anchor="ctr">
             <a:noAutofit/>
           </a:bodyPr>
           <a:lstStyle/>
@@ -22824,7 +22855,7 @@
               <a:defRPr/>
             </a:pPr>
             <a:r>
-              <a:rPr kumimoji="0" lang="en-US" sz="6400" b="1" i="0" u="none" strike="noStrike" kern="1200" cap="none" spc="0" normalizeH="0" baseline="0" noProof="0" dirty="0">
+              <a:rPr kumimoji="0" lang="en-US" sz="2933" b="1" i="0" u="none" strike="noStrike" kern="1200" cap="none" spc="0" normalizeH="0" baseline="0" noProof="0" dirty="0">
                 <a:ln>
                   <a:noFill/>
                 </a:ln>
@@ -22838,14 +22869,14 @@
                 <a:ea typeface="Calibri"/>
                 <a:cs typeface="+mn-cs"/>
               </a:rPr>
-              <a:t>Transformer – Encoder Decoder</a:t>
+              <a:t>Transformer Architecture</a:t>
             </a:r>
-            <a:endParaRPr kumimoji="0" lang="en-US" sz="6400" b="0" i="0" u="none" strike="noStrike" kern="1200" cap="none" spc="0" normalizeH="0" baseline="0" noProof="0" dirty="0">
+            <a:endParaRPr kumimoji="0" lang="en-US" sz="2933" b="0" i="0" u="none" strike="noStrike" kern="1200" cap="none" spc="0" normalizeH="0" baseline="0" noProof="0" dirty="0">
               <a:ln>
                 <a:noFill/>
               </a:ln>
               <a:solidFill>
-                <a:srgbClr val="FFFFFF"/>
+                <a:srgbClr val="000000"/>
               </a:solidFill>
               <a:effectLst/>
               <a:uLnTx/>
@@ -22859,10 +22890,10 @@
       </p:sp>
       <p:sp>
         <p:nvSpPr>
-          <p:cNvPr id="10" name="Shape 2">
+          <p:cNvPr id="195" name="Shape 2">
             <a:extLst>
               <a:ext uri="{FF2B5EF4-FFF2-40B4-BE49-F238E27FC236}">
-                <a16:creationId xmlns:a16="http://schemas.microsoft.com/office/drawing/2014/main" id="{F16397B7-8C20-F937-B132-C3ACE2E663EA}"/>
+                <a16:creationId xmlns:a16="http://schemas.microsoft.com/office/drawing/2014/main" id="{25EA78FC-2E3C-C65A-CE2F-A0FEDBAF034D}"/>
               </a:ext>
             </a:extLst>
           </p:cNvPr>
@@ -22871,14 +22902,14 @@
         </p:nvSpPr>
         <p:spPr>
           <a:xfrm>
-            <a:off x="426720" y="3596640"/>
-            <a:ext cx="11460000" cy="48480"/>
+            <a:off x="0" y="6559200"/>
+            <a:ext cx="12191520" cy="298080"/>
           </a:xfrm>
           <a:prstGeom prst="rect">
             <a:avLst/>
           </a:prstGeom>
           <a:solidFill>
-            <a:srgbClr val="00A8CC"/>
+            <a:srgbClr val="0D2340"/>
           </a:solidFill>
           <a:ln w="0">
             <a:noFill/>
@@ -22897,7 +22928,7 @@
           <a:fontRef idx="minor"/>
         </p:style>
         <p:txBody>
-          <a:bodyPr lIns="120000" tIns="-11040" rIns="120000" bIns="-11040" anchor="t">
+          <a:bodyPr lIns="120000" tIns="60000" rIns="120000" bIns="60000" anchor="t">
             <a:noAutofit/>
           </a:bodyPr>
           <a:lstStyle/>
@@ -22938,10 +22969,10 @@
       </p:sp>
       <p:sp>
         <p:nvSpPr>
-          <p:cNvPr id="12" name="Text 4">
+          <p:cNvPr id="4" name="Text 3">
             <a:extLst>
               <a:ext uri="{FF2B5EF4-FFF2-40B4-BE49-F238E27FC236}">
-                <a16:creationId xmlns:a16="http://schemas.microsoft.com/office/drawing/2014/main" id="{BC7F60AA-27A9-A494-1459-F3288FF28C56}"/>
+                <a16:creationId xmlns:a16="http://schemas.microsoft.com/office/drawing/2014/main" id="{8A122B40-E040-F8D1-F9F8-DFB1B43039B4}"/>
               </a:ext>
             </a:extLst>
           </p:cNvPr>
@@ -22950,36 +22981,20 @@
         </p:nvSpPr>
         <p:spPr>
           <a:xfrm>
-            <a:off x="426720" y="5608320"/>
-            <a:ext cx="11338080" cy="365280"/>
+            <a:off x="329184" y="6615684"/>
+            <a:ext cx="6217920" cy="190065"/>
           </a:xfrm>
           <a:prstGeom prst="rect">
             <a:avLst/>
           </a:prstGeom>
           <a:noFill/>
-          <a:ln w="0">
-            <a:noFill/>
-          </a:ln>
+          <a:ln/>
         </p:spPr>
-        <p:style>
-          <a:lnRef idx="0">
-            <a:scrgbClr r="0" g="0" b="0"/>
-          </a:lnRef>
-          <a:fillRef idx="0">
-            <a:scrgbClr r="0" g="0" b="0"/>
-          </a:fillRef>
-          <a:effectRef idx="0">
-            <a:scrgbClr r="0" g="0" b="0"/>
-          </a:effectRef>
-          <a:fontRef idx="minor"/>
-        </p:style>
         <p:txBody>
-          <a:bodyPr lIns="120000" tIns="60000" rIns="120000" bIns="60000" anchor="ctr">
-            <a:noAutofit/>
-          </a:bodyPr>
+          <a:bodyPr wrap="square" lIns="0" tIns="0" rIns="0" bIns="0" rtlCol="0" anchor="ctr"/>
           <a:lstStyle/>
           <a:p>
-            <a:pPr marL="0" marR="0" lvl="0" indent="0" algn="l" defTabSz="1219170" rtl="0" eaLnBrk="1" fontAlgn="auto" latinLnBrk="0" hangingPunct="1">
+            <a:pPr marL="0" marR="0" lvl="0" indent="0" algn="l" defTabSz="914400" rtl="0" eaLnBrk="1" fontAlgn="auto" latinLnBrk="0" hangingPunct="1">
               <a:lnSpc>
                 <a:spcPct val="100000"/>
               </a:lnSpc>
@@ -22993,13 +23008,11 @@
               <a:buSzTx/>
               <a:buFontTx/>
               <a:buNone/>
-              <a:tabLst>
-                <a:tab pos="0" algn="l"/>
-              </a:tabLst>
+              <a:tabLst/>
               <a:defRPr/>
             </a:pPr>
             <a:r>
-              <a:rPr kumimoji="0" lang="en-US" sz="1733" b="0" i="0" u="none" strike="noStrike" kern="1200" cap="none" spc="0" normalizeH="0" baseline="0" noProof="0" dirty="0">
+              <a:rPr kumimoji="0" lang="en-US" sz="1400" b="0" i="0" u="none" strike="noStrike" kern="1200" cap="none" spc="0" normalizeH="0" baseline="0" noProof="0" dirty="0">
                 <a:ln>
                   <a:noFill/>
                 </a:ln>
@@ -23009,33 +23022,859 @@
                 <a:effectLst/>
                 <a:uLnTx/>
                 <a:uFillTx/>
-                <a:latin typeface="Calibri"/>
-                <a:ea typeface="Calibri"/>
+                <a:latin typeface="Calibri" panose="020F0502020204030204"/>
+                <a:ea typeface="+mn-ea"/>
                 <a:cs typeface="+mn-cs"/>
               </a:rPr>
-              <a:t>DS 207 Final Project  ·  Team: Greed and Fear  ·  Author: Diogo Viveiros ·  March 27, 2026</a:t>
+              <a:t>DATASCI 207  ·  Final Project: Forecasting Volatility In Stock Market  ·  March 2026</a:t>
             </a:r>
-            <a:endParaRPr kumimoji="0" lang="en-US" sz="1733" b="0" i="0" u="none" strike="noStrike" kern="1200" cap="none" spc="0" normalizeH="0" baseline="0" noProof="0" dirty="0">
+            <a:endParaRPr kumimoji="0" lang="en-US" sz="1250" b="0" i="0" u="none" strike="noStrike" kern="1200" cap="none" spc="0" normalizeH="0" baseline="0" noProof="0" dirty="0">
               <a:ln>
                 <a:noFill/>
               </a:ln>
               <a:solidFill>
-                <a:srgbClr val="FFFFFF"/>
+                <a:srgbClr val="000000"/>
               </a:solidFill>
               <a:effectLst/>
               <a:uLnTx/>
               <a:uFillTx/>
-              <a:latin typeface="Arial"/>
+              <a:latin typeface="Calibri" panose="020F0502020204030204"/>
               <a:ea typeface="+mn-ea"/>
               <a:cs typeface="+mn-cs"/>
             </a:endParaRPr>
+          </a:p>
+        </p:txBody>
+      </p:sp>
+      <p:sp>
+        <p:nvSpPr>
+          <p:cNvPr id="2" name="TextBox 1">
+            <a:extLst>
+              <a:ext uri="{FF2B5EF4-FFF2-40B4-BE49-F238E27FC236}">
+                <a16:creationId xmlns:a16="http://schemas.microsoft.com/office/drawing/2014/main" id="{0870CFB9-4B26-2894-8661-BA6673A471DF}"/>
+              </a:ext>
+            </a:extLst>
+          </p:cNvPr>
+          <p:cNvSpPr txBox="1"/>
+          <p:nvPr/>
+        </p:nvSpPr>
+        <p:spPr>
+          <a:xfrm>
+            <a:off x="749969" y="1455923"/>
+            <a:ext cx="2041278" cy="369332"/>
+          </a:xfrm>
+          <a:prstGeom prst="rect">
+            <a:avLst/>
+          </a:prstGeom>
+          <a:noFill/>
+          <a:ln>
+            <a:solidFill>
+              <a:schemeClr val="accent2">
+                <a:lumMod val="75000"/>
+              </a:schemeClr>
+            </a:solidFill>
+          </a:ln>
+        </p:spPr>
+        <p:txBody>
+          <a:bodyPr wrap="square" rtlCol="0">
+            <a:spAutoFit/>
+          </a:bodyPr>
+          <a:lstStyle/>
+          <a:p>
+            <a:pPr algn="ctr"/>
+            <a:r>
+              <a:rPr lang="en-US" dirty="0"/>
+              <a:t>Dropout</a:t>
+            </a:r>
+          </a:p>
+        </p:txBody>
+      </p:sp>
+      <p:sp>
+        <p:nvSpPr>
+          <p:cNvPr id="3" name="TextBox 2">
+            <a:extLst>
+              <a:ext uri="{FF2B5EF4-FFF2-40B4-BE49-F238E27FC236}">
+                <a16:creationId xmlns:a16="http://schemas.microsoft.com/office/drawing/2014/main" id="{DEB08ABF-949D-163A-587D-185E01E58033}"/>
+              </a:ext>
+            </a:extLst>
+          </p:cNvPr>
+          <p:cNvSpPr txBox="1"/>
+          <p:nvPr/>
+        </p:nvSpPr>
+        <p:spPr>
+          <a:xfrm>
+            <a:off x="749969" y="3246812"/>
+            <a:ext cx="2041278" cy="646331"/>
+          </a:xfrm>
+          <a:prstGeom prst="rect">
+            <a:avLst/>
+          </a:prstGeom>
+          <a:noFill/>
+          <a:ln>
+            <a:solidFill>
+              <a:schemeClr val="accent2">
+                <a:lumMod val="75000"/>
+              </a:schemeClr>
+            </a:solidFill>
+          </a:ln>
+        </p:spPr>
+        <p:txBody>
+          <a:bodyPr wrap="square" rtlCol="0">
+            <a:spAutoFit/>
+          </a:bodyPr>
+          <a:lstStyle/>
+          <a:p>
+            <a:pPr algn="ctr"/>
+            <a:r>
+              <a:rPr lang="en-US" dirty="0"/>
+              <a:t>Transformer Encoding Block</a:t>
+            </a:r>
+          </a:p>
+        </p:txBody>
+      </p:sp>
+      <p:sp>
+        <p:nvSpPr>
+          <p:cNvPr id="5" name="TextBox 4">
+            <a:extLst>
+              <a:ext uri="{FF2B5EF4-FFF2-40B4-BE49-F238E27FC236}">
+                <a16:creationId xmlns:a16="http://schemas.microsoft.com/office/drawing/2014/main" id="{CA528BCE-327B-1CB6-F87D-C54FA2B735AB}"/>
+              </a:ext>
+            </a:extLst>
+          </p:cNvPr>
+          <p:cNvSpPr txBox="1"/>
+          <p:nvPr/>
+        </p:nvSpPr>
+        <p:spPr>
+          <a:xfrm>
+            <a:off x="749969" y="4204510"/>
+            <a:ext cx="2041278" cy="369332"/>
+          </a:xfrm>
+          <a:prstGeom prst="rect">
+            <a:avLst/>
+          </a:prstGeom>
+          <a:noFill/>
+          <a:ln>
+            <a:solidFill>
+              <a:schemeClr val="accent2">
+                <a:lumMod val="75000"/>
+              </a:schemeClr>
+            </a:solidFill>
+          </a:ln>
+        </p:spPr>
+        <p:txBody>
+          <a:bodyPr wrap="square" rtlCol="0">
+            <a:spAutoFit/>
+          </a:bodyPr>
+          <a:lstStyle/>
+          <a:p>
+            <a:pPr algn="ctr"/>
+            <a:r>
+              <a:rPr lang="en-US" dirty="0"/>
+              <a:t>Flatten</a:t>
+            </a:r>
+          </a:p>
+        </p:txBody>
+      </p:sp>
+      <p:sp>
+        <p:nvSpPr>
+          <p:cNvPr id="6" name="TextBox 5">
+            <a:extLst>
+              <a:ext uri="{FF2B5EF4-FFF2-40B4-BE49-F238E27FC236}">
+                <a16:creationId xmlns:a16="http://schemas.microsoft.com/office/drawing/2014/main" id="{438BC5EE-3ADB-33D9-5AE5-6E23971A2A3E}"/>
+              </a:ext>
+            </a:extLst>
+          </p:cNvPr>
+          <p:cNvSpPr txBox="1"/>
+          <p:nvPr/>
+        </p:nvSpPr>
+        <p:spPr>
+          <a:xfrm>
+            <a:off x="749969" y="4859660"/>
+            <a:ext cx="2041278" cy="369332"/>
+          </a:xfrm>
+          <a:prstGeom prst="rect">
+            <a:avLst/>
+          </a:prstGeom>
+          <a:noFill/>
+          <a:ln>
+            <a:solidFill>
+              <a:schemeClr val="accent2">
+                <a:lumMod val="75000"/>
+              </a:schemeClr>
+            </a:solidFill>
+          </a:ln>
+        </p:spPr>
+        <p:txBody>
+          <a:bodyPr wrap="square" rtlCol="0">
+            <a:spAutoFit/>
+          </a:bodyPr>
+          <a:lstStyle/>
+          <a:p>
+            <a:pPr algn="ctr"/>
+            <a:r>
+              <a:rPr lang="en-US" dirty="0"/>
+              <a:t>Dropout</a:t>
+            </a:r>
+          </a:p>
+        </p:txBody>
+      </p:sp>
+      <p:sp>
+        <p:nvSpPr>
+          <p:cNvPr id="7" name="TextBox 6">
+            <a:extLst>
+              <a:ext uri="{FF2B5EF4-FFF2-40B4-BE49-F238E27FC236}">
+                <a16:creationId xmlns:a16="http://schemas.microsoft.com/office/drawing/2014/main" id="{0D113A92-F124-84E5-EB81-D595C10FB129}"/>
+              </a:ext>
+            </a:extLst>
+          </p:cNvPr>
+          <p:cNvSpPr txBox="1"/>
+          <p:nvPr/>
+        </p:nvSpPr>
+        <p:spPr>
+          <a:xfrm>
+            <a:off x="6003758" y="4166393"/>
+            <a:ext cx="2041278" cy="369332"/>
+          </a:xfrm>
+          <a:prstGeom prst="rect">
+            <a:avLst/>
+          </a:prstGeom>
+          <a:noFill/>
+          <a:ln>
+            <a:solidFill>
+              <a:schemeClr val="accent2">
+                <a:lumMod val="75000"/>
+              </a:schemeClr>
+            </a:solidFill>
+          </a:ln>
+        </p:spPr>
+        <p:txBody>
+          <a:bodyPr wrap="square" rtlCol="0">
+            <a:spAutoFit/>
+          </a:bodyPr>
+          <a:lstStyle/>
+          <a:p>
+            <a:pPr algn="ctr"/>
+            <a:r>
+              <a:rPr lang="en-US" dirty="0"/>
+              <a:t>Output (Dense)</a:t>
+            </a:r>
+          </a:p>
+        </p:txBody>
+      </p:sp>
+      <p:sp>
+        <p:nvSpPr>
+          <p:cNvPr id="8" name="TextBox 7">
+            <a:extLst>
+              <a:ext uri="{FF2B5EF4-FFF2-40B4-BE49-F238E27FC236}">
+                <a16:creationId xmlns:a16="http://schemas.microsoft.com/office/drawing/2014/main" id="{4564BE52-ED4C-6D14-7826-6418EB2361F0}"/>
+              </a:ext>
+            </a:extLst>
+          </p:cNvPr>
+          <p:cNvSpPr txBox="1"/>
+          <p:nvPr/>
+        </p:nvSpPr>
+        <p:spPr>
+          <a:xfrm>
+            <a:off x="749969" y="950727"/>
+            <a:ext cx="2041278" cy="369332"/>
+          </a:xfrm>
+          <a:prstGeom prst="rect">
+            <a:avLst/>
+          </a:prstGeom>
+          <a:noFill/>
+          <a:ln>
+            <a:solidFill>
+              <a:schemeClr val="accent2">
+                <a:lumMod val="75000"/>
+              </a:schemeClr>
+            </a:solidFill>
+          </a:ln>
+        </p:spPr>
+        <p:txBody>
+          <a:bodyPr wrap="square" rtlCol="0">
+            <a:spAutoFit/>
+          </a:bodyPr>
+          <a:lstStyle/>
+          <a:p>
+            <a:pPr algn="ctr"/>
+            <a:r>
+              <a:rPr lang="en-US" dirty="0"/>
+              <a:t>Input</a:t>
+            </a:r>
+          </a:p>
+        </p:txBody>
+      </p:sp>
+      <p:sp>
+        <p:nvSpPr>
+          <p:cNvPr id="19" name="TextBox 18">
+            <a:extLst>
+              <a:ext uri="{FF2B5EF4-FFF2-40B4-BE49-F238E27FC236}">
+                <a16:creationId xmlns:a16="http://schemas.microsoft.com/office/drawing/2014/main" id="{D6D1258B-C130-0483-DD7A-B77E58D43034}"/>
+              </a:ext>
+            </a:extLst>
+          </p:cNvPr>
+          <p:cNvSpPr txBox="1"/>
+          <p:nvPr/>
+        </p:nvSpPr>
+        <p:spPr>
+          <a:xfrm>
+            <a:off x="6003758" y="1527121"/>
+            <a:ext cx="2041278" cy="646331"/>
+          </a:xfrm>
+          <a:prstGeom prst="rect">
+            <a:avLst/>
+          </a:prstGeom>
+          <a:noFill/>
+          <a:ln>
+            <a:solidFill>
+              <a:schemeClr val="accent2">
+                <a:lumMod val="75000"/>
+              </a:schemeClr>
+            </a:solidFill>
+          </a:ln>
+        </p:spPr>
+        <p:txBody>
+          <a:bodyPr wrap="square" rtlCol="0">
+            <a:spAutoFit/>
+          </a:bodyPr>
+          <a:lstStyle/>
+          <a:p>
+            <a:pPr algn="ctr"/>
+            <a:r>
+              <a:rPr lang="en-US" dirty="0"/>
+              <a:t>Multi-Head Attention</a:t>
+            </a:r>
+          </a:p>
+        </p:txBody>
+      </p:sp>
+      <p:sp>
+        <p:nvSpPr>
+          <p:cNvPr id="20" name="TextBox 19">
+            <a:extLst>
+              <a:ext uri="{FF2B5EF4-FFF2-40B4-BE49-F238E27FC236}">
+                <a16:creationId xmlns:a16="http://schemas.microsoft.com/office/drawing/2014/main" id="{F7B8377E-B092-3257-7DCD-CDD3302D8554}"/>
+              </a:ext>
+            </a:extLst>
+          </p:cNvPr>
+          <p:cNvSpPr txBox="1"/>
+          <p:nvPr/>
+        </p:nvSpPr>
+        <p:spPr>
+          <a:xfrm>
+            <a:off x="770022" y="2683074"/>
+            <a:ext cx="2041278" cy="369332"/>
+          </a:xfrm>
+          <a:prstGeom prst="rect">
+            <a:avLst/>
+          </a:prstGeom>
+          <a:noFill/>
+          <a:ln>
+            <a:solidFill>
+              <a:schemeClr val="accent2">
+                <a:lumMod val="75000"/>
+              </a:schemeClr>
+            </a:solidFill>
+          </a:ln>
+        </p:spPr>
+        <p:txBody>
+          <a:bodyPr wrap="square" rtlCol="0">
+            <a:spAutoFit/>
+          </a:bodyPr>
+          <a:lstStyle/>
+          <a:p>
+            <a:pPr algn="ctr"/>
+            <a:r>
+              <a:rPr lang="en-US" dirty="0"/>
+              <a:t>(…) * </a:t>
+            </a:r>
+            <a:r>
+              <a:rPr lang="en-US" dirty="0" err="1"/>
+              <a:t>num_blocks</a:t>
+            </a:r>
+            <a:endParaRPr lang="en-US" dirty="0"/>
+          </a:p>
+        </p:txBody>
+      </p:sp>
+      <p:sp>
+        <p:nvSpPr>
+          <p:cNvPr id="21" name="TextBox 20">
+            <a:extLst>
+              <a:ext uri="{FF2B5EF4-FFF2-40B4-BE49-F238E27FC236}">
+                <a16:creationId xmlns:a16="http://schemas.microsoft.com/office/drawing/2014/main" id="{36E37091-D872-BFFB-075A-329D839F96C4}"/>
+              </a:ext>
+            </a:extLst>
+          </p:cNvPr>
+          <p:cNvSpPr txBox="1"/>
+          <p:nvPr/>
+        </p:nvSpPr>
+        <p:spPr>
+          <a:xfrm>
+            <a:off x="6003758" y="983010"/>
+            <a:ext cx="2041278" cy="369332"/>
+          </a:xfrm>
+          <a:prstGeom prst="rect">
+            <a:avLst/>
+          </a:prstGeom>
+          <a:noFill/>
+          <a:ln>
+            <a:solidFill>
+              <a:schemeClr val="accent2">
+                <a:lumMod val="75000"/>
+              </a:schemeClr>
+            </a:solidFill>
+          </a:ln>
+        </p:spPr>
+        <p:txBody>
+          <a:bodyPr wrap="square" rtlCol="0">
+            <a:spAutoFit/>
+          </a:bodyPr>
+          <a:lstStyle/>
+          <a:p>
+            <a:pPr algn="ctr"/>
+            <a:r>
+              <a:rPr lang="en-US" dirty="0"/>
+              <a:t>Input</a:t>
+            </a:r>
+          </a:p>
+        </p:txBody>
+      </p:sp>
+      <p:sp>
+        <p:nvSpPr>
+          <p:cNvPr id="22" name="TextBox 21">
+            <a:extLst>
+              <a:ext uri="{FF2B5EF4-FFF2-40B4-BE49-F238E27FC236}">
+                <a16:creationId xmlns:a16="http://schemas.microsoft.com/office/drawing/2014/main" id="{63403F21-289D-73F9-AA1A-C6DF43B9B34A}"/>
+              </a:ext>
+            </a:extLst>
+          </p:cNvPr>
+          <p:cNvSpPr txBox="1"/>
+          <p:nvPr/>
+        </p:nvSpPr>
+        <p:spPr>
+          <a:xfrm>
+            <a:off x="770022" y="1916604"/>
+            <a:ext cx="2041278" cy="646331"/>
+          </a:xfrm>
+          <a:prstGeom prst="rect">
+            <a:avLst/>
+          </a:prstGeom>
+          <a:noFill/>
+          <a:ln>
+            <a:solidFill>
+              <a:schemeClr val="accent2">
+                <a:lumMod val="75000"/>
+              </a:schemeClr>
+            </a:solidFill>
+          </a:ln>
+        </p:spPr>
+        <p:txBody>
+          <a:bodyPr wrap="square" rtlCol="0">
+            <a:spAutoFit/>
+          </a:bodyPr>
+          <a:lstStyle/>
+          <a:p>
+            <a:pPr algn="ctr"/>
+            <a:r>
+              <a:rPr lang="en-US" dirty="0"/>
+              <a:t>Transformer Encoding Block</a:t>
+            </a:r>
+          </a:p>
+        </p:txBody>
+      </p:sp>
+      <p:sp>
+        <p:nvSpPr>
+          <p:cNvPr id="23" name="TextBox 22">
+            <a:extLst>
+              <a:ext uri="{FF2B5EF4-FFF2-40B4-BE49-F238E27FC236}">
+                <a16:creationId xmlns:a16="http://schemas.microsoft.com/office/drawing/2014/main" id="{4B47D3AF-C9D3-FA35-1853-078438049BD2}"/>
+              </a:ext>
+            </a:extLst>
+          </p:cNvPr>
+          <p:cNvSpPr txBox="1"/>
+          <p:nvPr/>
+        </p:nvSpPr>
+        <p:spPr>
+          <a:xfrm>
+            <a:off x="6003758" y="2344296"/>
+            <a:ext cx="2041278" cy="369332"/>
+          </a:xfrm>
+          <a:prstGeom prst="rect">
+            <a:avLst/>
+          </a:prstGeom>
+          <a:noFill/>
+          <a:ln>
+            <a:solidFill>
+              <a:schemeClr val="accent2">
+                <a:lumMod val="75000"/>
+              </a:schemeClr>
+            </a:solidFill>
+          </a:ln>
+        </p:spPr>
+        <p:txBody>
+          <a:bodyPr wrap="square" rtlCol="0">
+            <a:spAutoFit/>
+          </a:bodyPr>
+          <a:lstStyle/>
+          <a:p>
+            <a:pPr algn="ctr"/>
+            <a:r>
+              <a:rPr lang="en-US" dirty="0"/>
+              <a:t>Dropout</a:t>
+            </a:r>
+          </a:p>
+        </p:txBody>
+      </p:sp>
+      <p:sp>
+        <p:nvSpPr>
+          <p:cNvPr id="24" name="TextBox 23">
+            <a:extLst>
+              <a:ext uri="{FF2B5EF4-FFF2-40B4-BE49-F238E27FC236}">
+                <a16:creationId xmlns:a16="http://schemas.microsoft.com/office/drawing/2014/main" id="{D7591C0A-B87D-CCF0-3F46-63E4A9F6870B}"/>
+              </a:ext>
+            </a:extLst>
+          </p:cNvPr>
+          <p:cNvSpPr txBox="1"/>
+          <p:nvPr/>
+        </p:nvSpPr>
+        <p:spPr>
+          <a:xfrm>
+            <a:off x="6003758" y="2857736"/>
+            <a:ext cx="2041278" cy="369332"/>
+          </a:xfrm>
+          <a:prstGeom prst="rect">
+            <a:avLst/>
+          </a:prstGeom>
+          <a:noFill/>
+          <a:ln>
+            <a:solidFill>
+              <a:schemeClr val="accent2">
+                <a:lumMod val="75000"/>
+              </a:schemeClr>
+            </a:solidFill>
+          </a:ln>
+        </p:spPr>
+        <p:txBody>
+          <a:bodyPr wrap="square" rtlCol="0">
+            <a:spAutoFit/>
+          </a:bodyPr>
+          <a:lstStyle/>
+          <a:p>
+            <a:pPr algn="ctr"/>
+            <a:r>
+              <a:rPr lang="en-US" dirty="0"/>
+              <a:t>Layer Normalization</a:t>
+            </a:r>
+          </a:p>
+        </p:txBody>
+      </p:sp>
+      <p:sp>
+        <p:nvSpPr>
+          <p:cNvPr id="25" name="TextBox 24">
+            <a:extLst>
+              <a:ext uri="{FF2B5EF4-FFF2-40B4-BE49-F238E27FC236}">
+                <a16:creationId xmlns:a16="http://schemas.microsoft.com/office/drawing/2014/main" id="{ED97A854-F98B-D02D-53EB-EB50400E59C2}"/>
+              </a:ext>
+            </a:extLst>
+          </p:cNvPr>
+          <p:cNvSpPr txBox="1"/>
+          <p:nvPr/>
+        </p:nvSpPr>
+        <p:spPr>
+          <a:xfrm>
+            <a:off x="6003758" y="3372068"/>
+            <a:ext cx="2041278" cy="646331"/>
+          </a:xfrm>
+          <a:prstGeom prst="rect">
+            <a:avLst/>
+          </a:prstGeom>
+          <a:noFill/>
+          <a:ln>
+            <a:solidFill>
+              <a:schemeClr val="accent2">
+                <a:lumMod val="75000"/>
+              </a:schemeClr>
+            </a:solidFill>
+          </a:ln>
+        </p:spPr>
+        <p:txBody>
+          <a:bodyPr wrap="square" rtlCol="0">
+            <a:spAutoFit/>
+          </a:bodyPr>
+          <a:lstStyle/>
+          <a:p>
+            <a:pPr algn="ctr"/>
+            <a:r>
+              <a:rPr lang="en-US" dirty="0"/>
+              <a:t>Residual Connection</a:t>
+            </a:r>
+          </a:p>
+        </p:txBody>
+      </p:sp>
+      <p:sp>
+        <p:nvSpPr>
+          <p:cNvPr id="26" name="TextBox 25">
+            <a:extLst>
+              <a:ext uri="{FF2B5EF4-FFF2-40B4-BE49-F238E27FC236}">
+                <a16:creationId xmlns:a16="http://schemas.microsoft.com/office/drawing/2014/main" id="{7CC1D007-DD36-5A0B-A6C1-2B762F74AE73}"/>
+              </a:ext>
+            </a:extLst>
+          </p:cNvPr>
+          <p:cNvSpPr txBox="1"/>
+          <p:nvPr/>
+        </p:nvSpPr>
+        <p:spPr>
+          <a:xfrm>
+            <a:off x="770022" y="5519589"/>
+            <a:ext cx="2041278" cy="369332"/>
+          </a:xfrm>
+          <a:prstGeom prst="rect">
+            <a:avLst/>
+          </a:prstGeom>
+          <a:noFill/>
+          <a:ln>
+            <a:solidFill>
+              <a:schemeClr val="accent2">
+                <a:lumMod val="75000"/>
+              </a:schemeClr>
+            </a:solidFill>
+          </a:ln>
+        </p:spPr>
+        <p:txBody>
+          <a:bodyPr wrap="square" rtlCol="0">
+            <a:spAutoFit/>
+          </a:bodyPr>
+          <a:lstStyle/>
+          <a:p>
+            <a:pPr algn="ctr"/>
+            <a:r>
+              <a:rPr lang="en-US" dirty="0"/>
+              <a:t>Output (Dense)</a:t>
+            </a:r>
+          </a:p>
+        </p:txBody>
+      </p:sp>
+      <p:sp>
+        <p:nvSpPr>
+          <p:cNvPr id="27" name="TextBox 26">
+            <a:extLst>
+              <a:ext uri="{FF2B5EF4-FFF2-40B4-BE49-F238E27FC236}">
+                <a16:creationId xmlns:a16="http://schemas.microsoft.com/office/drawing/2014/main" id="{FEF92617-62B3-ADB4-A145-24AAC788AECB}"/>
+              </a:ext>
+            </a:extLst>
+          </p:cNvPr>
+          <p:cNvSpPr txBox="1"/>
+          <p:nvPr/>
+        </p:nvSpPr>
+        <p:spPr>
+          <a:xfrm>
+            <a:off x="6003758" y="4659598"/>
+            <a:ext cx="2041278" cy="369332"/>
+          </a:xfrm>
+          <a:prstGeom prst="rect">
+            <a:avLst/>
+          </a:prstGeom>
+          <a:noFill/>
+          <a:ln>
+            <a:solidFill>
+              <a:schemeClr val="accent2">
+                <a:lumMod val="75000"/>
+              </a:schemeClr>
+            </a:solidFill>
+          </a:ln>
+        </p:spPr>
+        <p:txBody>
+          <a:bodyPr wrap="square" rtlCol="0">
+            <a:spAutoFit/>
+          </a:bodyPr>
+          <a:lstStyle/>
+          <a:p>
+            <a:pPr algn="ctr"/>
+            <a:r>
+              <a:rPr lang="en-US" dirty="0"/>
+              <a:t>Dropout</a:t>
+            </a:r>
+          </a:p>
+        </p:txBody>
+      </p:sp>
+      <p:sp>
+        <p:nvSpPr>
+          <p:cNvPr id="28" name="TextBox 27">
+            <a:extLst>
+              <a:ext uri="{FF2B5EF4-FFF2-40B4-BE49-F238E27FC236}">
+                <a16:creationId xmlns:a16="http://schemas.microsoft.com/office/drawing/2014/main" id="{0203846B-C309-2CF7-8142-203665518D2F}"/>
+              </a:ext>
+            </a:extLst>
+          </p:cNvPr>
+          <p:cNvSpPr txBox="1"/>
+          <p:nvPr/>
+        </p:nvSpPr>
+        <p:spPr>
+          <a:xfrm>
+            <a:off x="6003758" y="5833844"/>
+            <a:ext cx="2041278" cy="369332"/>
+          </a:xfrm>
+          <a:prstGeom prst="rect">
+            <a:avLst/>
+          </a:prstGeom>
+          <a:noFill/>
+          <a:ln>
+            <a:solidFill>
+              <a:schemeClr val="accent2">
+                <a:lumMod val="75000"/>
+              </a:schemeClr>
+            </a:solidFill>
+          </a:ln>
+        </p:spPr>
+        <p:txBody>
+          <a:bodyPr wrap="square" rtlCol="0">
+            <a:spAutoFit/>
+          </a:bodyPr>
+          <a:lstStyle/>
+          <a:p>
+            <a:pPr algn="ctr"/>
+            <a:r>
+              <a:rPr lang="en-US" dirty="0"/>
+              <a:t>Layer Normalization</a:t>
+            </a:r>
+          </a:p>
+        </p:txBody>
+      </p:sp>
+      <p:cxnSp>
+        <p:nvCxnSpPr>
+          <p:cNvPr id="38" name="Straight Connector 37">
+            <a:extLst>
+              <a:ext uri="{FF2B5EF4-FFF2-40B4-BE49-F238E27FC236}">
+                <a16:creationId xmlns:a16="http://schemas.microsoft.com/office/drawing/2014/main" id="{38991300-090C-E97E-B17D-BFE1A1138A39}"/>
+              </a:ext>
+            </a:extLst>
+          </p:cNvPr>
+          <p:cNvCxnSpPr>
+            <a:stCxn id="22" idx="3"/>
+          </p:cNvCxnSpPr>
+          <p:nvPr/>
+        </p:nvCxnSpPr>
+        <p:spPr>
+          <a:xfrm flipV="1">
+            <a:off x="2811300" y="733926"/>
+            <a:ext cx="2765337" cy="1505844"/>
+          </a:xfrm>
+          <a:prstGeom prst="line">
+            <a:avLst/>
+          </a:prstGeom>
+          <a:ln>
+            <a:solidFill>
+              <a:schemeClr val="accent1">
+                <a:lumMod val="75000"/>
+              </a:schemeClr>
+            </a:solidFill>
+          </a:ln>
+        </p:spPr>
+        <p:style>
+          <a:lnRef idx="1">
+            <a:schemeClr val="accent1"/>
+          </a:lnRef>
+          <a:fillRef idx="0">
+            <a:schemeClr val="accent1"/>
+          </a:fillRef>
+          <a:effectRef idx="0">
+            <a:schemeClr val="accent1"/>
+          </a:effectRef>
+          <a:fontRef idx="minor">
+            <a:schemeClr val="tx1"/>
+          </a:fontRef>
+        </p:style>
+      </p:cxnSp>
+      <p:cxnSp>
+        <p:nvCxnSpPr>
+          <p:cNvPr id="40" name="Straight Connector 39">
+            <a:extLst>
+              <a:ext uri="{FF2B5EF4-FFF2-40B4-BE49-F238E27FC236}">
+                <a16:creationId xmlns:a16="http://schemas.microsoft.com/office/drawing/2014/main" id="{22A927AD-5B85-23FD-4E11-34CED8E90B09}"/>
+              </a:ext>
+            </a:extLst>
+          </p:cNvPr>
+          <p:cNvCxnSpPr>
+            <a:stCxn id="22" idx="3"/>
+          </p:cNvCxnSpPr>
+          <p:nvPr/>
+        </p:nvCxnSpPr>
+        <p:spPr>
+          <a:xfrm>
+            <a:off x="2811300" y="2239770"/>
+            <a:ext cx="2765337" cy="4028683"/>
+          </a:xfrm>
+          <a:prstGeom prst="line">
+            <a:avLst/>
+          </a:prstGeom>
+          <a:ln>
+            <a:solidFill>
+              <a:schemeClr val="accent1">
+                <a:lumMod val="75000"/>
+              </a:schemeClr>
+            </a:solidFill>
+          </a:ln>
+        </p:spPr>
+        <p:style>
+          <a:lnRef idx="1">
+            <a:schemeClr val="accent1"/>
+          </a:lnRef>
+          <a:fillRef idx="0">
+            <a:schemeClr val="accent1"/>
+          </a:fillRef>
+          <a:effectRef idx="0">
+            <a:schemeClr val="accent1"/>
+          </a:effectRef>
+          <a:fontRef idx="minor">
+            <a:schemeClr val="tx1"/>
+          </a:fontRef>
+        </p:style>
+      </p:cxnSp>
+      <p:sp>
+        <p:nvSpPr>
+          <p:cNvPr id="41" name="TextBox 40">
+            <a:extLst>
+              <a:ext uri="{FF2B5EF4-FFF2-40B4-BE49-F238E27FC236}">
+                <a16:creationId xmlns:a16="http://schemas.microsoft.com/office/drawing/2014/main" id="{40C4A20F-3671-E4EB-DB4C-166F58967F90}"/>
+              </a:ext>
+            </a:extLst>
+          </p:cNvPr>
+          <p:cNvSpPr txBox="1"/>
+          <p:nvPr/>
+        </p:nvSpPr>
+        <p:spPr>
+          <a:xfrm>
+            <a:off x="6003758" y="5117491"/>
+            <a:ext cx="2041278" cy="646331"/>
+          </a:xfrm>
+          <a:prstGeom prst="rect">
+            <a:avLst/>
+          </a:prstGeom>
+          <a:noFill/>
+          <a:ln>
+            <a:solidFill>
+              <a:schemeClr val="accent2">
+                <a:lumMod val="75000"/>
+              </a:schemeClr>
+            </a:solidFill>
+          </a:ln>
+        </p:spPr>
+        <p:txBody>
+          <a:bodyPr wrap="square" rtlCol="0">
+            <a:spAutoFit/>
+          </a:bodyPr>
+          <a:lstStyle/>
+          <a:p>
+            <a:pPr algn="ctr"/>
+            <a:r>
+              <a:rPr lang="en-US" dirty="0"/>
+              <a:t>Residual Connection</a:t>
+            </a:r>
           </a:p>
         </p:txBody>
       </p:sp>
     </p:spTree>
     <p:extLst>
       <p:ext uri="{BB962C8B-B14F-4D97-AF65-F5344CB8AC3E}">
-        <p14:creationId xmlns:p14="http://schemas.microsoft.com/office/powerpoint/2010/main" val="3680748600"/>
+        <p14:creationId xmlns:p14="http://schemas.microsoft.com/office/powerpoint/2010/main" val="2411045518"/>
       </p:ext>
     </p:extLst>
   </p:cSld>
@@ -23425,20 +24264,12 @@
 <file path=ppt/slides/slide20.xml><?xml version="1.0" encoding="utf-8"?>
 <p:sld xmlns:a="http://schemas.openxmlformats.org/drawingml/2006/main" xmlns:r="http://schemas.openxmlformats.org/officeDocument/2006/relationships" xmlns:p="http://schemas.openxmlformats.org/presentationml/2006/main">
   <p:cSld>
-    <p:bg>
-      <p:bgPr>
-        <a:solidFill>
-          <a:srgbClr val="F5F6F8"/>
-        </a:solidFill>
-        <a:effectLst/>
-      </p:bgPr>
-    </p:bg>
     <p:spTree>
       <p:nvGrpSpPr>
         <p:cNvPr id="1" name="">
           <a:extLst>
             <a:ext uri="{FF2B5EF4-FFF2-40B4-BE49-F238E27FC236}">
-              <a16:creationId xmlns:a16="http://schemas.microsoft.com/office/drawing/2014/main" id="{4E1D813E-DC0D-3B45-E96E-CAFA3CD09888}"/>
+              <a16:creationId xmlns:a16="http://schemas.microsoft.com/office/drawing/2014/main" id="{701DBFFE-0F17-BE17-C085-4D7CE7DB798D}"/>
             </a:ext>
           </a:extLst>
         </p:cNvPr>
@@ -23458,7 +24289,7 @@
           <p:cNvPr id="193" name="Shape 0">
             <a:extLst>
               <a:ext uri="{FF2B5EF4-FFF2-40B4-BE49-F238E27FC236}">
-                <a16:creationId xmlns:a16="http://schemas.microsoft.com/office/drawing/2014/main" id="{C6C2E10A-9B75-B261-FB8F-D8E7B9FFC6C3}"/>
+                <a16:creationId xmlns:a16="http://schemas.microsoft.com/office/drawing/2014/main" id="{BA5D1521-A975-62B4-7009-3ED44389C968}"/>
               </a:ext>
             </a:extLst>
           </p:cNvPr>
@@ -23537,7 +24368,7 @@
           <p:cNvPr id="194" name="Text 1">
             <a:extLst>
               <a:ext uri="{FF2B5EF4-FFF2-40B4-BE49-F238E27FC236}">
-                <a16:creationId xmlns:a16="http://schemas.microsoft.com/office/drawing/2014/main" id="{90CC156E-CB02-D9E6-1ED9-071A7A098FC2}"/>
+                <a16:creationId xmlns:a16="http://schemas.microsoft.com/office/drawing/2014/main" id="{54A5A41F-1A68-349F-402B-831A8A2A3690}"/>
               </a:ext>
             </a:extLst>
           </p:cNvPr>
@@ -23595,6 +24426,23 @@
               <a:defRPr/>
             </a:pPr>
             <a:r>
+              <a:rPr kumimoji="0" lang="en-US" sz="2933" b="1" i="0" u="none" strike="noStrike" kern="1200" cap="none" spc="0" normalizeH="0" baseline="0" noProof="0" dirty="0" err="1">
+                <a:ln>
+                  <a:noFill/>
+                </a:ln>
+                <a:solidFill>
+                  <a:srgbClr val="FFFFFF"/>
+                </a:solidFill>
+                <a:effectLst/>
+                <a:uLnTx/>
+                <a:uFillTx/>
+                <a:latin typeface="Calibri"/>
+                <a:ea typeface="Calibri"/>
+                <a:cs typeface="+mn-cs"/>
+              </a:rPr>
+              <a:t>HyperParameter</a:t>
+            </a:r>
+            <a:r>
               <a:rPr kumimoji="0" lang="en-US" sz="2933" b="1" i="0" u="none" strike="noStrike" kern="1200" cap="none" spc="0" normalizeH="0" baseline="0" noProof="0" dirty="0">
                 <a:ln>
                   <a:noFill/>
@@ -23609,7 +24457,7 @@
                 <a:ea typeface="Calibri"/>
                 <a:cs typeface="+mn-cs"/>
               </a:rPr>
-              <a:t>Title</a:t>
+              <a:t> Considerations</a:t>
             </a:r>
             <a:endParaRPr kumimoji="0" lang="en-US" sz="2933" b="0" i="0" u="none" strike="noStrike" kern="1200" cap="none" spc="0" normalizeH="0" baseline="0" noProof="0" dirty="0">
               <a:ln>
@@ -23633,7 +24481,7 @@
           <p:cNvPr id="195" name="Shape 2">
             <a:extLst>
               <a:ext uri="{FF2B5EF4-FFF2-40B4-BE49-F238E27FC236}">
-                <a16:creationId xmlns:a16="http://schemas.microsoft.com/office/drawing/2014/main" id="{7456C7B9-DA81-2A24-F2A4-299E2121EC58}"/>
+                <a16:creationId xmlns:a16="http://schemas.microsoft.com/office/drawing/2014/main" id="{FBC1FD78-FD30-0A72-C7CA-698F2495413F}"/>
               </a:ext>
             </a:extLst>
           </p:cNvPr>
@@ -23712,7 +24560,7 @@
           <p:cNvPr id="198" name="Shape 4">
             <a:extLst>
               <a:ext uri="{FF2B5EF4-FFF2-40B4-BE49-F238E27FC236}">
-                <a16:creationId xmlns:a16="http://schemas.microsoft.com/office/drawing/2014/main" id="{4F5358EF-10A5-F85B-BBDF-BD9C762EC02B}"/>
+                <a16:creationId xmlns:a16="http://schemas.microsoft.com/office/drawing/2014/main" id="{5AB5D28C-9A1F-C87A-8F3E-7AF3199BF489}"/>
               </a:ext>
             </a:extLst>
           </p:cNvPr>
@@ -23794,7 +24642,7 @@
           <p:cNvPr id="199" name="Text 5">
             <a:extLst>
               <a:ext uri="{FF2B5EF4-FFF2-40B4-BE49-F238E27FC236}">
-                <a16:creationId xmlns:a16="http://schemas.microsoft.com/office/drawing/2014/main" id="{61A5CB75-9AEB-D196-53C3-E861747D099F}"/>
+                <a16:creationId xmlns:a16="http://schemas.microsoft.com/office/drawing/2014/main" id="{A2C6D975-D190-8677-FC56-3088AB785B61}"/>
               </a:ext>
             </a:extLst>
           </p:cNvPr>
@@ -23852,19 +24700,12 @@
               <a:defRPr/>
             </a:pPr>
             <a:r>
-              <a:rPr kumimoji="0" lang="en-US" sz="1733" b="1" i="0" u="none" strike="noStrike" kern="1200" cap="none" spc="0" normalizeH="0" baseline="0" noProof="0" dirty="0">
-                <a:ln>
-                  <a:noFill/>
-                </a:ln>
+              <a:rPr lang="en-US" sz="1733" b="1" dirty="0">
                 <a:solidFill>
                   <a:srgbClr val="00A8CC"/>
                 </a:solidFill>
-                <a:effectLst/>
-                <a:uLnTx/>
-                <a:uFillTx/>
                 <a:latin typeface="Calibri"/>
                 <a:ea typeface="Calibri"/>
-                <a:cs typeface="+mn-cs"/>
               </a:rPr>
               <a:t>Heading</a:t>
             </a:r>
@@ -23890,7 +24731,7 @@
           <p:cNvPr id="200" name="Text 6">
             <a:extLst>
               <a:ext uri="{FF2B5EF4-FFF2-40B4-BE49-F238E27FC236}">
-                <a16:creationId xmlns:a16="http://schemas.microsoft.com/office/drawing/2014/main" id="{E0844E72-B496-845F-223F-6DD454A8B180}"/>
+                <a16:creationId xmlns:a16="http://schemas.microsoft.com/office/drawing/2014/main" id="{C2FD3EE1-9CA4-1E58-4783-B1EE0963F7DF}"/>
               </a:ext>
             </a:extLst>
           </p:cNvPr>
@@ -23962,7 +24803,62 @@
                 <a:ea typeface="Calibri"/>
                 <a:cs typeface="+mn-cs"/>
               </a:rPr>
-              <a:t>Bullet.</a:t>
+              <a:t>Number of Encoder Blocks: Keep it Simple</a:t>
+            </a:r>
+          </a:p>
+          <a:p>
+            <a:pPr marL="228594" marR="0" lvl="0" indent="-228594" algn="l" defTabSz="1219170" rtl="0" eaLnBrk="1" fontAlgn="auto" latinLnBrk="0" hangingPunct="1">
+              <a:lnSpc>
+                <a:spcPct val="100000"/>
+              </a:lnSpc>
+              <a:spcBef>
+                <a:spcPts val="0"/>
+              </a:spcBef>
+              <a:spcAft>
+                <a:spcPts val="665"/>
+              </a:spcAft>
+              <a:buClr>
+                <a:srgbClr val="1A1A2E"/>
+              </a:buClr>
+              <a:buSzTx/>
+              <a:buFont typeface="Arial" panose="020B0604020202020204" pitchFamily="34" charset="0"/>
+              <a:buChar char="•"/>
+              <a:tabLst/>
+              <a:defRPr/>
+            </a:pPr>
+            <a:r>
+              <a:rPr kumimoji="0" lang="en-US" sz="1600" b="1" i="0" u="none" strike="noStrike" kern="1200" cap="none" spc="0" normalizeH="0" baseline="0" noProof="0" dirty="0" err="1">
+                <a:ln>
+                  <a:noFill/>
+                </a:ln>
+                <a:solidFill>
+                  <a:srgbClr val="000000"/>
+                </a:solidFill>
+                <a:effectLst/>
+                <a:uLnTx/>
+                <a:uFillTx/>
+                <a:latin typeface="Calibri" panose="020F0502020204030204"/>
+                <a:ea typeface="+mn-ea"/>
+                <a:cs typeface="+mn-cs"/>
+              </a:rPr>
+              <a:t>Head_Size</a:t>
+            </a:r>
+            <a:r>
+              <a:rPr kumimoji="0" lang="en-US" sz="1600" b="1" i="0" u="none" strike="noStrike" kern="1200" cap="none" spc="0" normalizeH="0" baseline="0" noProof="0" dirty="0">
+                <a:ln>
+                  <a:noFill/>
+                </a:ln>
+                <a:solidFill>
+                  <a:srgbClr val="000000"/>
+                </a:solidFill>
+                <a:effectLst/>
+                <a:uLnTx/>
+                <a:uFillTx/>
+                <a:latin typeface="Calibri" panose="020F0502020204030204"/>
+                <a:ea typeface="+mn-ea"/>
+                <a:cs typeface="+mn-cs"/>
+              </a:rPr>
+              <a:t>: Number of days remembered per </a:t>
             </a:r>
           </a:p>
           <a:p>
@@ -24000,7 +24896,7 @@
                 <a:ea typeface="+mn-ea"/>
                 <a:cs typeface="+mn-cs"/>
               </a:rPr>
-              <a:t>Bullet.</a:t>
+              <a:t>Dropout percentage: Needs considerable dropout layers</a:t>
             </a:r>
           </a:p>
           <a:p>
@@ -24038,8 +24934,31 @@
                 <a:ea typeface="+mn-ea"/>
                 <a:cs typeface="+mn-cs"/>
               </a:rPr>
-              <a:t>Bullet.</a:t>
+              <a:t>Feed-Forward Dimension</a:t>
             </a:r>
+            <a:r>
+              <a:rPr lang="en-US" sz="1600" b="1" dirty="0">
+                <a:solidFill>
+                  <a:srgbClr val="000000"/>
+                </a:solidFill>
+                <a:latin typeface="Calibri" panose="020F0502020204030204"/>
+              </a:rPr>
+              <a:t>:</a:t>
+            </a:r>
+            <a:endParaRPr kumimoji="0" lang="en-US" sz="1600" b="1" i="0" u="none" strike="noStrike" kern="1200" cap="none" spc="0" normalizeH="0" baseline="0" noProof="0" dirty="0">
+              <a:ln>
+                <a:noFill/>
+              </a:ln>
+              <a:solidFill>
+                <a:srgbClr val="000000"/>
+              </a:solidFill>
+              <a:effectLst/>
+              <a:uLnTx/>
+              <a:uFillTx/>
+              <a:latin typeface="Calibri" panose="020F0502020204030204"/>
+              <a:ea typeface="+mn-ea"/>
+              <a:cs typeface="+mn-cs"/>
+            </a:endParaRPr>
           </a:p>
           <a:p>
             <a:pPr marL="228594" marR="0" lvl="0" indent="-228594" algn="l" defTabSz="1219170" rtl="0" eaLnBrk="1" fontAlgn="auto" latinLnBrk="0" hangingPunct="1">
@@ -24076,45 +24995,7 @@
                 <a:ea typeface="+mn-ea"/>
                 <a:cs typeface="+mn-cs"/>
               </a:rPr>
-              <a:t>Bullet.</a:t>
-            </a:r>
-          </a:p>
-          <a:p>
-            <a:pPr marL="228594" marR="0" lvl="0" indent="-228594" algn="l" defTabSz="1219170" rtl="0" eaLnBrk="1" fontAlgn="auto" latinLnBrk="0" hangingPunct="1">
-              <a:lnSpc>
-                <a:spcPct val="100000"/>
-              </a:lnSpc>
-              <a:spcBef>
-                <a:spcPts val="0"/>
-              </a:spcBef>
-              <a:spcAft>
-                <a:spcPts val="665"/>
-              </a:spcAft>
-              <a:buClr>
-                <a:srgbClr val="1A1A2E"/>
-              </a:buClr>
-              <a:buSzTx/>
-              <a:buFont typeface="Arial" panose="020B0604020202020204" pitchFamily="34" charset="0"/>
-              <a:buChar char="•"/>
-              <a:tabLst/>
-              <a:defRPr/>
-            </a:pPr>
-            <a:r>
-              <a:rPr kumimoji="0" lang="en-US" sz="1600" b="1" i="0" u="none" strike="noStrike" kern="1200" cap="none" spc="0" normalizeH="0" baseline="0" noProof="0" dirty="0">
-                <a:ln>
-                  <a:noFill/>
-                </a:ln>
-                <a:solidFill>
-                  <a:srgbClr val="000000"/>
-                </a:solidFill>
-                <a:effectLst/>
-                <a:uLnTx/>
-                <a:uFillTx/>
-                <a:latin typeface="Calibri" panose="020F0502020204030204"/>
-                <a:ea typeface="+mn-ea"/>
-                <a:cs typeface="+mn-cs"/>
-              </a:rPr>
-              <a:t>Bullet.</a:t>
+              <a:t>Epochs: Never needs more than a few, but they run slow</a:t>
             </a:r>
           </a:p>
         </p:txBody>
@@ -24124,7 +25005,7 @@
           <p:cNvPr id="4" name="Text 3">
             <a:extLst>
               <a:ext uri="{FF2B5EF4-FFF2-40B4-BE49-F238E27FC236}">
-                <a16:creationId xmlns:a16="http://schemas.microsoft.com/office/drawing/2014/main" id="{0EEDB539-78F0-1724-28E9-D08494646B32}"/>
+                <a16:creationId xmlns:a16="http://schemas.microsoft.com/office/drawing/2014/main" id="{06444588-BB72-25C9-DEBA-0D3D5F03A725}"/>
               </a:ext>
             </a:extLst>
           </p:cNvPr>
@@ -24200,7 +25081,7 @@
     </p:spTree>
     <p:extLst>
       <p:ext uri="{BB962C8B-B14F-4D97-AF65-F5344CB8AC3E}">
-        <p14:creationId xmlns:p14="http://schemas.microsoft.com/office/powerpoint/2010/main" val="1064745833"/>
+        <p14:creationId xmlns:p14="http://schemas.microsoft.com/office/powerpoint/2010/main" val="1364739842"/>
       </p:ext>
     </p:extLst>
   </p:cSld>
@@ -24511,7 +25392,7 @@
             </p:custDataLst>
             <p:extLst>
               <p:ext uri="{D42A27DB-BD31-4B8C-83A1-F6EECF244321}">
-                <p14:modId xmlns:p14="http://schemas.microsoft.com/office/powerpoint/2010/main" val="1850384220"/>
+                <p14:modId xmlns:p14="http://schemas.microsoft.com/office/powerpoint/2010/main" val="728612292"/>
               </p:ext>
             </p:extLst>
           </p:nvPr>
@@ -24989,7 +25870,7 @@
                         </a:tabLst>
                       </a:pPr>
                       <a:r>
-                        <a:rPr lang="en-US" sz="1400" b="1" u="none" strike="noStrike">
+                        <a:rPr lang="en-US" sz="1400" b="1" u="none" strike="noStrike" dirty="0">
                           <a:solidFill>
                             <a:srgbClr val="000000"/>
                           </a:solidFill>
@@ -25000,7 +25881,7 @@
                         </a:rPr>
                         <a:t>0.0855</a:t>
                       </a:r>
-                      <a:endParaRPr lang="en-US" sz="1400" b="1" u="none" strike="noStrike">
+                      <a:endParaRPr lang="en-US" sz="1400" b="1" u="none" strike="noStrike" dirty="0">
                         <a:solidFill>
                           <a:srgbClr val="000000"/>
                         </a:solidFill>
@@ -25726,7 +26607,7 @@
                           <a:tab pos="0" algn="l"/>
                         </a:tabLst>
                       </a:pPr>
-                      <a:endParaRPr lang="en-US" sz="1400" b="1" u="none" strike="noStrike">
+                      <a:endParaRPr lang="en-US" sz="1400" b="1" u="none" strike="noStrike" dirty="0">
                         <a:solidFill>
                           <a:srgbClr val="000000"/>
                         </a:solidFill>
@@ -25849,7 +26730,7 @@
                           <a:tab pos="0" algn="l"/>
                         </a:tabLst>
                       </a:pPr>
-                      <a:endParaRPr lang="en-US" sz="1400" b="1" u="none" strike="noStrike">
+                      <a:endParaRPr lang="en-US" sz="1400" b="1" u="none" strike="noStrike" dirty="0">
                         <a:solidFill>
                           <a:srgbClr val="000000"/>
                         </a:solidFill>
@@ -26419,13 +27300,15 @@
                           <a:tab pos="0" algn="l"/>
                         </a:tabLst>
                       </a:pPr>
-                      <a:endParaRPr lang="en-US" sz="1400" b="1" u="none" strike="noStrike">
+                      <a:endParaRPr lang="en-US" sz="1400" b="1" u="none" strike="noStrike" kern="1200" dirty="0">
                         <a:solidFill>
                           <a:srgbClr val="000000"/>
                         </a:solidFill>
                         <a:effectLst/>
                         <a:uFillTx/>
-                        <a:latin typeface="Arial"/>
+                        <a:latin typeface="Calibri"/>
+                        <a:ea typeface="Calibri"/>
+                        <a:cs typeface="+mn-cs"/>
                       </a:endParaRPr>
                     </a:p>
                   </a:txBody>
@@ -26482,13 +27365,15 @@
                           <a:tab pos="0" algn="l"/>
                         </a:tabLst>
                       </a:pPr>
-                      <a:endParaRPr lang="en-US" sz="1400" b="1" u="none" strike="noStrike" dirty="0">
+                      <a:endParaRPr lang="en-US" sz="1400" b="1" u="none" strike="noStrike" kern="1200" dirty="0">
                         <a:solidFill>
                           <a:srgbClr val="000000"/>
                         </a:solidFill>
                         <a:effectLst/>
                         <a:uFillTx/>
-                        <a:latin typeface="Arial"/>
+                        <a:latin typeface="Calibri"/>
+                        <a:ea typeface="Calibri"/>
+                        <a:cs typeface="+mn-cs"/>
                       </a:endParaRPr>
                     </a:p>
                   </a:txBody>
@@ -26545,13 +27430,15 @@
                           <a:tab pos="0" algn="l"/>
                         </a:tabLst>
                       </a:pPr>
-                      <a:endParaRPr lang="en-US" sz="1400" b="1" u="none" strike="noStrike">
+                      <a:endParaRPr lang="en-US" sz="1400" b="1" u="none" strike="noStrike" kern="1200" dirty="0">
                         <a:solidFill>
                           <a:srgbClr val="000000"/>
                         </a:solidFill>
                         <a:effectLst/>
                         <a:uFillTx/>
-                        <a:latin typeface="Arial"/>
+                        <a:latin typeface="Calibri"/>
+                        <a:ea typeface="Calibri"/>
+                        <a:cs typeface="+mn-cs"/>
                       </a:endParaRPr>
                     </a:p>
                   </a:txBody>
@@ -26770,13 +27657,15 @@
                           <a:tab pos="0" algn="l"/>
                         </a:tabLst>
                       </a:pPr>
-                      <a:endParaRPr lang="en-US" sz="1400" b="0" u="none" strike="noStrike" dirty="0">
+                      <a:endParaRPr lang="en-US" sz="1400" b="1" u="none" strike="noStrike" kern="1200" dirty="0">
                         <a:solidFill>
                           <a:srgbClr val="000000"/>
                         </a:solidFill>
                         <a:effectLst/>
                         <a:uFillTx/>
-                        <a:latin typeface="Arial"/>
+                        <a:latin typeface="Calibri"/>
+                        <a:ea typeface="Calibri"/>
+                        <a:cs typeface="+mn-cs"/>
                       </a:endParaRPr>
                     </a:p>
                   </a:txBody>
@@ -26835,13 +27724,15 @@
                           <a:tab pos="0" algn="l"/>
                         </a:tabLst>
                       </a:pPr>
-                      <a:endParaRPr lang="en-US" sz="1400" b="0" u="none" strike="noStrike" dirty="0">
+                      <a:endParaRPr lang="en-US" sz="1400" b="1" u="none" strike="noStrike" kern="1200" dirty="0">
                         <a:solidFill>
                           <a:srgbClr val="000000"/>
                         </a:solidFill>
                         <a:effectLst/>
                         <a:uFillTx/>
-                        <a:latin typeface="Arial"/>
+                        <a:latin typeface="Calibri"/>
+                        <a:ea typeface="Calibri"/>
+                        <a:cs typeface="+mn-cs"/>
                       </a:endParaRPr>
                     </a:p>
                   </a:txBody>
@@ -26897,13 +27788,15 @@
                           <a:tab pos="0" algn="l"/>
                         </a:tabLst>
                       </a:pPr>
-                      <a:endParaRPr lang="en-US" sz="1400" b="0" u="none" strike="noStrike" dirty="0">
+                      <a:endParaRPr lang="en-US" sz="1400" b="1" u="none" strike="noStrike" kern="1200" dirty="0">
                         <a:solidFill>
                           <a:srgbClr val="000000"/>
                         </a:solidFill>
                         <a:effectLst/>
                         <a:uFillTx/>
-                        <a:latin typeface="Arial"/>
+                        <a:latin typeface="Calibri"/>
+                        <a:ea typeface="Calibri"/>
+                        <a:cs typeface="+mn-cs"/>
                       </a:endParaRPr>
                     </a:p>
                   </a:txBody>
@@ -27035,19 +27928,7 @@
                           <a:latin typeface="Calibri"/>
                           <a:ea typeface="Calibri"/>
                         </a:rPr>
-                        <a:t>Transformer-Encoder Decoder</a:t>
-                      </a:r>
-                      <a:r>
-                        <a:rPr lang="en-US" sz="1400" b="1" u="none" strike="noStrike" dirty="0">
-                          <a:solidFill>
-                            <a:srgbClr val="000000"/>
-                          </a:solidFill>
-                          <a:effectLst/>
-                          <a:uFillTx/>
-                          <a:latin typeface="+mn-lt"/>
-                          <a:ea typeface="Calibri"/>
-                        </a:rPr>
-                        <a:t>— V1</a:t>
+                        <a:t>Transformer-Encoder (Diogo) – V1</a:t>
                       </a:r>
                       <a:endParaRPr lang="en-US" sz="1400" b="0" u="none" strike="noStrike" dirty="0">
                         <a:solidFill>
@@ -27109,13 +27990,15 @@
                           <a:tab pos="0" algn="l"/>
                         </a:tabLst>
                       </a:pPr>
-                      <a:endParaRPr lang="en-US" sz="1400" b="1" u="none" strike="noStrike">
+                      <a:endParaRPr lang="en-US" sz="1400" b="1" u="none" strike="noStrike" kern="1200" dirty="0">
                         <a:solidFill>
                           <a:srgbClr val="000000"/>
                         </a:solidFill>
                         <a:effectLst/>
                         <a:uFillTx/>
-                        <a:latin typeface="Arial"/>
+                        <a:latin typeface="Calibri"/>
+                        <a:ea typeface="Calibri"/>
+                        <a:cs typeface="+mn-cs"/>
                       </a:endParaRPr>
                     </a:p>
                   </a:txBody>
@@ -27172,13 +28055,15 @@
                           <a:tab pos="0" algn="l"/>
                         </a:tabLst>
                       </a:pPr>
-                      <a:endParaRPr lang="en-US" sz="1400" b="1" u="none" strike="noStrike" dirty="0">
+                      <a:endParaRPr lang="en-US" sz="1400" b="1" u="none" strike="noStrike" kern="1200" dirty="0">
                         <a:solidFill>
                           <a:srgbClr val="000000"/>
                         </a:solidFill>
                         <a:effectLst/>
                         <a:uFillTx/>
-                        <a:latin typeface="Arial"/>
+                        <a:latin typeface="Calibri"/>
+                        <a:ea typeface="Calibri"/>
+                        <a:cs typeface="+mn-cs"/>
                       </a:endParaRPr>
                     </a:p>
                   </a:txBody>
@@ -27235,13 +28120,15 @@
                           <a:tab pos="0" algn="l"/>
                         </a:tabLst>
                       </a:pPr>
-                      <a:endParaRPr lang="en-US" sz="1400" b="1" u="none" strike="noStrike">
+                      <a:endParaRPr lang="en-US" sz="1400" b="1" u="none" strike="noStrike" kern="1200" dirty="0">
                         <a:solidFill>
                           <a:srgbClr val="000000"/>
                         </a:solidFill>
                         <a:effectLst/>
                         <a:uFillTx/>
-                        <a:latin typeface="Arial"/>
+                        <a:latin typeface="Calibri"/>
+                        <a:ea typeface="Calibri"/>
+                        <a:cs typeface="+mn-cs"/>
                       </a:endParaRPr>
                     </a:p>
                   </a:txBody>
@@ -27375,31 +28262,7 @@
                           <a:latin typeface="+mn-lt"/>
                           <a:ea typeface="Calibri"/>
                         </a:rPr>
-                        <a:t>Transformer-Encoder Decoder—</a:t>
-                      </a:r>
-                      <a:r>
-                        <a:rPr lang="en-US" sz="1400" b="1" u="none" strike="noStrike" dirty="0">
-                          <a:solidFill>
-                            <a:srgbClr val="000000"/>
-                          </a:solidFill>
-                          <a:effectLst/>
-                          <a:uFillTx/>
-                          <a:latin typeface="+mn-lt"/>
-                          <a:ea typeface="Calibri"/>
-                        </a:rPr>
-                        <a:t> </a:t>
-                      </a:r>
-                      <a:r>
-                        <a:rPr lang="en-US" sz="1400" b="1" u="none" strike="noStrike" dirty="0">
-                          <a:solidFill>
-                            <a:srgbClr val="00A8CC"/>
-                          </a:solidFill>
-                          <a:effectLst/>
-                          <a:uFillTx/>
-                          <a:latin typeface="+mn-lt"/>
-                          <a:ea typeface="Calibri"/>
-                        </a:rPr>
-                        <a:t>V2</a:t>
+                        <a:t>Transformer-Encoder (Diogo) – V2</a:t>
                       </a:r>
                       <a:endParaRPr lang="en-US" sz="1400" b="0" u="none" strike="noStrike" dirty="0">
                         <a:solidFill>
@@ -27460,14 +28323,19 @@
                           <a:tab pos="0" algn="l"/>
                         </a:tabLst>
                       </a:pPr>
-                      <a:endParaRPr lang="en-US" sz="1400" b="0" u="none" strike="noStrike" dirty="0">
-                        <a:solidFill>
-                          <a:srgbClr val="000000"/>
-                        </a:solidFill>
-                        <a:effectLst/>
-                        <a:uFillTx/>
-                        <a:latin typeface="Arial"/>
-                      </a:endParaRPr>
+                      <a:r>
+                        <a:rPr lang="en-US" sz="1400" b="1" u="none" strike="noStrike" kern="1200" dirty="0">
+                          <a:solidFill>
+                            <a:srgbClr val="000000"/>
+                          </a:solidFill>
+                          <a:effectLst/>
+                          <a:uFillTx/>
+                          <a:latin typeface="Calibri"/>
+                          <a:ea typeface="Calibri"/>
+                          <a:cs typeface="+mn-cs"/>
+                        </a:rPr>
+                        <a:t>0.1021 </a:t>
+                      </a:r>
                     </a:p>
                   </a:txBody>
                   <a:tcPr marL="121920" marR="121920" marT="60960" marB="60960" anchor="ctr">
@@ -27525,14 +28393,19 @@
                           <a:tab pos="0" algn="l"/>
                         </a:tabLst>
                       </a:pPr>
-                      <a:endParaRPr lang="en-US" sz="1400" b="0" u="none" strike="noStrike" dirty="0">
-                        <a:solidFill>
-                          <a:srgbClr val="000000"/>
-                        </a:solidFill>
-                        <a:effectLst/>
-                        <a:uFillTx/>
-                        <a:latin typeface="Arial"/>
-                      </a:endParaRPr>
+                      <a:r>
+                        <a:rPr lang="en-US" sz="1400" b="1" u="none" strike="noStrike" kern="1200" dirty="0">
+                          <a:solidFill>
+                            <a:srgbClr val="000000"/>
+                          </a:solidFill>
+                          <a:effectLst/>
+                          <a:uFillTx/>
+                          <a:latin typeface="Calibri"/>
+                          <a:ea typeface="Calibri"/>
+                          <a:cs typeface="+mn-cs"/>
+                        </a:rPr>
+                        <a:t>0.1506</a:t>
+                      </a:r>
                     </a:p>
                   </a:txBody>
                   <a:tcPr marL="121920" marR="121920" marT="60960" marB="60960" anchor="ctr">
@@ -27554,11 +28427,14 @@
                       <a:headEnd type="none" w="med" len="med"/>
                       <a:tailEnd type="none" w="med" len="med"/>
                     </a:lnR>
-                    <a:lnT w="6480">
-                      <a:solidFill>
-                        <a:srgbClr val="CCCCCC"/>
-                      </a:solidFill>
-                      <a:prstDash val="solid"/>
+                    <a:lnT w="6480" cap="flat" cmpd="sng" algn="ctr">
+                      <a:solidFill>
+                        <a:srgbClr val="CCCCCC"/>
+                      </a:solidFill>
+                      <a:prstDash val="solid"/>
+                      <a:round/>
+                      <a:headEnd type="none" w="med" len="med"/>
+                      <a:tailEnd type="none" w="med" len="med"/>
                     </a:lnT>
                     <a:lnB w="6480" cap="flat" cmpd="sng" algn="ctr">
                       <a:solidFill>
@@ -27587,14 +28463,19 @@
                           <a:tab pos="0" algn="l"/>
                         </a:tabLst>
                       </a:pPr>
-                      <a:endParaRPr lang="en-US" sz="1400" b="0" u="none" strike="noStrike" dirty="0">
-                        <a:solidFill>
-                          <a:srgbClr val="000000"/>
-                        </a:solidFill>
-                        <a:effectLst/>
-                        <a:uFillTx/>
-                        <a:latin typeface="Arial"/>
-                      </a:endParaRPr>
+                      <a:r>
+                        <a:rPr lang="en-US" sz="1400" b="1" u="none" strike="noStrike" kern="1200" dirty="0">
+                          <a:solidFill>
+                            <a:srgbClr val="000000"/>
+                          </a:solidFill>
+                          <a:effectLst/>
+                          <a:uFillTx/>
+                          <a:latin typeface="Calibri"/>
+                          <a:ea typeface="Calibri"/>
+                          <a:cs typeface="+mn-cs"/>
+                        </a:rPr>
+                        <a:t>0.0383</a:t>
+                      </a:r>
                     </a:p>
                   </a:txBody>
                   <a:tcPr marL="121920" marR="121920" marT="60960" marB="60960" anchor="ctr">
@@ -27616,11 +28497,14 @@
                       <a:headEnd type="none" w="med" len="med"/>
                       <a:tailEnd type="none" w="med" len="med"/>
                     </a:lnR>
-                    <a:lnT w="6480">
-                      <a:solidFill>
-                        <a:srgbClr val="CCCCCC"/>
-                      </a:solidFill>
-                      <a:prstDash val="solid"/>
+                    <a:lnT w="6480" cap="flat" cmpd="sng" algn="ctr">
+                      <a:solidFill>
+                        <a:srgbClr val="CCCCCC"/>
+                      </a:solidFill>
+                      <a:prstDash val="solid"/>
+                      <a:round/>
+                      <a:headEnd type="none" w="med" len="med"/>
+                      <a:tailEnd type="none" w="med" len="med"/>
                     </a:lnT>
                     <a:lnB w="6480" cap="flat" cmpd="sng" algn="ctr">
                       <a:solidFill>
@@ -40130,4 +41014,10 @@
     </a:ext>
   </a:extLst>
 </a:theme>
+</file>
+
+<file path=docMetadata/LabelInfo.xml><?xml version="1.0" encoding="utf-8"?>
+<clbl:labelList xmlns:clbl="http://schemas.microsoft.com/office/2020/mipLabelMetadata">
+  <clbl:label id="{f42aa342-8706-4288-bd11-ebb85995028c}" enabled="1" method="Standard" siteId="{72f988bf-86f1-41af-91ab-2d7cd011db47}" contentBits="0" removed="0"/>
+</clbl:labelList>
 </file>
</xml_diff>

<commit_message>
Added Hyper-Parameter Configurations Slide for Transformer Model
</commit_message>
<xml_diff>
--- a/slides/Forecasting Volatility In Stock Market.pptx
+++ b/slides/Forecasting Volatility In Stock Market.pptx
@@ -2368,7 +2368,145 @@
             <a:pPr indent="0">
               <a:buNone/>
             </a:pPr>
-            <a:endParaRPr lang="en-US" sz="1800" b="0" u="none" strike="noStrike">
+            <a:r>
+              <a:rPr lang="en-US" sz="1800" b="0" u="none" strike="noStrike" dirty="0">
+                <a:solidFill>
+                  <a:srgbClr val="000000"/>
+                </a:solidFill>
+                <a:effectLst/>
+                <a:uFillTx/>
+                <a:latin typeface="Arial"/>
+              </a:rPr>
+              <a:t>Building a transformer requires a lot of specific choices to optimize the hyperparameters in the architecture. </a:t>
+            </a:r>
+            <a:br>
+              <a:rPr lang="en-US" sz="1800" b="0" u="none" strike="noStrike" dirty="0">
+                <a:solidFill>
+                  <a:srgbClr val="000000"/>
+                </a:solidFill>
+                <a:effectLst/>
+                <a:uFillTx/>
+                <a:latin typeface="Arial"/>
+              </a:rPr>
+            </a:br>
+            <a:br>
+              <a:rPr lang="en-US" sz="1800" b="0" u="none" strike="noStrike" dirty="0">
+                <a:solidFill>
+                  <a:srgbClr val="000000"/>
+                </a:solidFill>
+                <a:effectLst/>
+                <a:uFillTx/>
+                <a:latin typeface="Arial"/>
+              </a:rPr>
+            </a:br>
+            <a:r>
+              <a:rPr lang="en-US" sz="1800" b="0" u="none" strike="noStrike" dirty="0">
+                <a:solidFill>
+                  <a:srgbClr val="000000"/>
+                </a:solidFill>
+                <a:effectLst/>
+                <a:uFillTx/>
+                <a:latin typeface="Arial"/>
+              </a:rPr>
+              <a:t>Due to its high memorization ability, we should keep the number of encoder blocks simple, approximately 2 to 4. Any more than that and we see a large amount of overfitting. </a:t>
+            </a:r>
+            <a:br>
+              <a:rPr lang="en-US" sz="1800" b="0" u="none" strike="noStrike" dirty="0">
+                <a:solidFill>
+                  <a:srgbClr val="000000"/>
+                </a:solidFill>
+                <a:effectLst/>
+                <a:uFillTx/>
+                <a:latin typeface="Arial"/>
+              </a:rPr>
+            </a:br>
+            <a:br>
+              <a:rPr lang="en-US" sz="1800" b="0" u="none" strike="noStrike" dirty="0">
+                <a:solidFill>
+                  <a:srgbClr val="000000"/>
+                </a:solidFill>
+                <a:effectLst/>
+                <a:uFillTx/>
+                <a:latin typeface="Arial"/>
+              </a:rPr>
+            </a:br>
+            <a:r>
+              <a:rPr lang="en-US" sz="1800" b="0" u="none" strike="noStrike" dirty="0">
+                <a:solidFill>
+                  <a:srgbClr val="000000"/>
+                </a:solidFill>
+                <a:effectLst/>
+                <a:uFillTx/>
+                <a:latin typeface="Arial"/>
+              </a:rPr>
+              <a:t>This is paired with the Dropout (or Mask Padding in Ronald’s model), making our model ignore random weights in order to force the model to generalize well, not just memorize all of the data it sees. </a:t>
+            </a:r>
+          </a:p>
+          <a:p>
+            <a:pPr indent="0">
+              <a:buNone/>
+            </a:pPr>
+            <a:endParaRPr lang="en-US" sz="1800" b="0" u="none" strike="noStrike" dirty="0">
+              <a:solidFill>
+                <a:srgbClr val="000000"/>
+              </a:solidFill>
+              <a:effectLst/>
+              <a:uFillTx/>
+              <a:latin typeface="Arial"/>
+            </a:endParaRPr>
+          </a:p>
+          <a:p>
+            <a:pPr indent="0">
+              <a:buNone/>
+            </a:pPr>
+            <a:r>
+              <a:rPr lang="en-US" sz="1800" b="0" u="none" strike="noStrike" dirty="0">
+                <a:solidFill>
+                  <a:srgbClr val="000000"/>
+                </a:solidFill>
+                <a:effectLst/>
+                <a:uFillTx/>
+                <a:latin typeface="Arial"/>
+              </a:rPr>
+              <a:t>Within the Encoder, we must make decisions on the Sequence length, Head Size, and the Feed Forward dimension. The Sequence Length determines how many days of history we look at (since one of our V2 variables looks at the past 20 days, I set this length to 21).</a:t>
+            </a:r>
+            <a:br>
+              <a:rPr lang="en-US" sz="1800" b="0" u="none" strike="noStrike" dirty="0">
+                <a:solidFill>
+                  <a:srgbClr val="000000"/>
+                </a:solidFill>
+                <a:effectLst/>
+                <a:uFillTx/>
+                <a:latin typeface="Arial"/>
+              </a:rPr>
+            </a:br>
+            <a:br>
+              <a:rPr lang="en-US" sz="1800" b="0" u="none" strike="noStrike" dirty="0">
+                <a:solidFill>
+                  <a:srgbClr val="000000"/>
+                </a:solidFill>
+                <a:effectLst/>
+                <a:uFillTx/>
+                <a:latin typeface="Arial"/>
+              </a:rPr>
+            </a:br>
+            <a:r>
+              <a:rPr lang="en-US" sz="1800" b="0" u="none" strike="noStrike" dirty="0">
+                <a:solidFill>
+                  <a:srgbClr val="000000"/>
+                </a:solidFill>
+                <a:effectLst/>
+                <a:uFillTx/>
+                <a:latin typeface="Arial"/>
+              </a:rPr>
+              <a:t>Choosing Epochs is tricky: Transformers learn slowly but are also extremely consuming per epoch to calculate. We have to set a high epoch limit and let them train over a lengthened period of time, and rely on Early Stopping to check when our performance plateaus. </a:t>
+            </a:r>
+          </a:p>
+          <a:p>
+            <a:pPr indent="0">
+              <a:buNone/>
+            </a:pPr>
+            <a:endParaRPr lang="en-US" sz="1800" b="0" u="none" strike="noStrike" dirty="0">
               <a:solidFill>
                 <a:srgbClr val="000000"/>
               </a:solidFill>
@@ -4317,7 +4455,7 @@
           <a:p>
             <a:fld id="{5BCAD085-E8A6-8845-BD4E-CB4CCA059FC4}" type="datetimeFigureOut">
               <a:rPr lang="en-US" smtClean="0"/>
-              <a:t>4/9/2026</a:t>
+              <a:t>4/10/2026</a:t>
             </a:fld>
             <a:endParaRPr lang="en-US"/>
           </a:p>
@@ -24426,23 +24564,6 @@
               <a:defRPr/>
             </a:pPr>
             <a:r>
-              <a:rPr kumimoji="0" lang="en-US" sz="2933" b="1" i="0" u="none" strike="noStrike" kern="1200" cap="none" spc="0" normalizeH="0" baseline="0" noProof="0" dirty="0" err="1">
-                <a:ln>
-                  <a:noFill/>
-                </a:ln>
-                <a:solidFill>
-                  <a:srgbClr val="FFFFFF"/>
-                </a:solidFill>
-                <a:effectLst/>
-                <a:uLnTx/>
-                <a:uFillTx/>
-                <a:latin typeface="Calibri"/>
-                <a:ea typeface="Calibri"/>
-                <a:cs typeface="+mn-cs"/>
-              </a:rPr>
-              <a:t>HyperParameter</a:t>
-            </a:r>
-            <a:r>
               <a:rPr kumimoji="0" lang="en-US" sz="2933" b="1" i="0" u="none" strike="noStrike" kern="1200" cap="none" spc="0" normalizeH="0" baseline="0" noProof="0" dirty="0">
                 <a:ln>
                   <a:noFill/>
@@ -24457,7 +24578,7 @@
                 <a:ea typeface="Calibri"/>
                 <a:cs typeface="+mn-cs"/>
               </a:rPr>
-              <a:t> Considerations</a:t>
+              <a:t>Hyper-Parameter Considerations</a:t>
             </a:r>
             <a:endParaRPr kumimoji="0" lang="en-US" sz="2933" b="0" i="0" u="none" strike="noStrike" kern="1200" cap="none" spc="0" normalizeH="0" baseline="0" noProof="0" dirty="0">
               <a:ln>
@@ -24552,451 +24673,6 @@
               <a:ea typeface="+mn-ea"/>
               <a:cs typeface="+mn-cs"/>
             </a:endParaRPr>
-          </a:p>
-        </p:txBody>
-      </p:sp>
-      <p:sp>
-        <p:nvSpPr>
-          <p:cNvPr id="198" name="Shape 4">
-            <a:extLst>
-              <a:ext uri="{FF2B5EF4-FFF2-40B4-BE49-F238E27FC236}">
-                <a16:creationId xmlns:a16="http://schemas.microsoft.com/office/drawing/2014/main" id="{5AB5D28C-9A1F-C87A-8F3E-7AF3199BF489}"/>
-              </a:ext>
-            </a:extLst>
-          </p:cNvPr>
-          <p:cNvSpPr/>
-          <p:nvPr/>
-        </p:nvSpPr>
-        <p:spPr>
-          <a:xfrm>
-            <a:off x="219600" y="1045032"/>
-            <a:ext cx="11752800" cy="2339365"/>
-          </a:xfrm>
-          <a:prstGeom prst="rect">
-            <a:avLst/>
-          </a:prstGeom>
-          <a:solidFill>
-            <a:srgbClr val="D6F2FA"/>
-          </a:solidFill>
-          <a:ln w="19050">
-            <a:solidFill>
-              <a:srgbClr val="00A8CC"/>
-            </a:solidFill>
-            <a:round/>
-          </a:ln>
-        </p:spPr>
-        <p:style>
-          <a:lnRef idx="0">
-            <a:scrgbClr r="0" g="0" b="0"/>
-          </a:lnRef>
-          <a:fillRef idx="0">
-            <a:scrgbClr r="0" g="0" b="0"/>
-          </a:fillRef>
-          <a:effectRef idx="0">
-            <a:scrgbClr r="0" g="0" b="0"/>
-          </a:effectRef>
-          <a:fontRef idx="minor"/>
-        </p:style>
-        <p:txBody>
-          <a:bodyPr lIns="120000" tIns="60000" rIns="120000" bIns="60000" anchor="t">
-            <a:noAutofit/>
-          </a:bodyPr>
-          <a:lstStyle/>
-          <a:p>
-            <a:pPr marL="0" marR="0" lvl="0" indent="0" algn="l" defTabSz="1219170" rtl="0" eaLnBrk="1" fontAlgn="auto" latinLnBrk="0" hangingPunct="1">
-              <a:lnSpc>
-                <a:spcPct val="100000"/>
-              </a:lnSpc>
-              <a:spcBef>
-                <a:spcPts val="0"/>
-              </a:spcBef>
-              <a:spcAft>
-                <a:spcPts val="0"/>
-              </a:spcAft>
-              <a:buClrTx/>
-              <a:buSzTx/>
-              <a:buFontTx/>
-              <a:buNone/>
-              <a:tabLst/>
-              <a:defRPr/>
-            </a:pPr>
-            <a:endParaRPr kumimoji="0" lang="en-US" sz="2400" b="0" i="0" u="none" strike="noStrike" kern="1200" cap="none" spc="0" normalizeH="0" baseline="0" noProof="0">
-              <a:ln>
-                <a:noFill/>
-              </a:ln>
-              <a:solidFill>
-                <a:srgbClr val="000000"/>
-              </a:solidFill>
-              <a:effectLst/>
-              <a:uLnTx/>
-              <a:uFillTx/>
-              <a:latin typeface="Arial"/>
-              <a:ea typeface="+mn-ea"/>
-              <a:cs typeface="+mn-cs"/>
-            </a:endParaRPr>
-          </a:p>
-        </p:txBody>
-      </p:sp>
-      <p:sp>
-        <p:nvSpPr>
-          <p:cNvPr id="199" name="Text 5">
-            <a:extLst>
-              <a:ext uri="{FF2B5EF4-FFF2-40B4-BE49-F238E27FC236}">
-                <a16:creationId xmlns:a16="http://schemas.microsoft.com/office/drawing/2014/main" id="{A2C6D975-D190-8677-FC56-3088AB785B61}"/>
-              </a:ext>
-            </a:extLst>
-          </p:cNvPr>
-          <p:cNvSpPr/>
-          <p:nvPr/>
-        </p:nvSpPr>
-        <p:spPr>
-          <a:xfrm>
-            <a:off x="341520" y="1103040"/>
-            <a:ext cx="3535200" cy="365280"/>
-          </a:xfrm>
-          <a:prstGeom prst="rect">
-            <a:avLst/>
-          </a:prstGeom>
-          <a:noFill/>
-          <a:ln w="0">
-            <a:noFill/>
-          </a:ln>
-        </p:spPr>
-        <p:style>
-          <a:lnRef idx="0">
-            <a:scrgbClr r="0" g="0" b="0"/>
-          </a:lnRef>
-          <a:fillRef idx="0">
-            <a:scrgbClr r="0" g="0" b="0"/>
-          </a:fillRef>
-          <a:effectRef idx="0">
-            <a:scrgbClr r="0" g="0" b="0"/>
-          </a:effectRef>
-          <a:fontRef idx="minor"/>
-        </p:style>
-        <p:txBody>
-          <a:bodyPr lIns="120000" tIns="60000" rIns="120000" bIns="60000" anchor="ctr">
-            <a:noAutofit/>
-          </a:bodyPr>
-          <a:lstStyle/>
-          <a:p>
-            <a:pPr marL="0" marR="0" lvl="0" indent="0" algn="l" defTabSz="1219170" rtl="0" eaLnBrk="1" fontAlgn="auto" latinLnBrk="0" hangingPunct="1">
-              <a:lnSpc>
-                <a:spcPct val="100000"/>
-              </a:lnSpc>
-              <a:spcBef>
-                <a:spcPts val="0"/>
-              </a:spcBef>
-              <a:spcAft>
-                <a:spcPts val="0"/>
-              </a:spcAft>
-              <a:buClrTx/>
-              <a:buSzTx/>
-              <a:buFontTx/>
-              <a:buNone/>
-              <a:tabLst>
-                <a:tab pos="0" algn="l"/>
-              </a:tabLst>
-              <a:defRPr/>
-            </a:pPr>
-            <a:r>
-              <a:rPr lang="en-US" sz="1733" b="1" dirty="0">
-                <a:solidFill>
-                  <a:srgbClr val="00A8CC"/>
-                </a:solidFill>
-                <a:latin typeface="Calibri"/>
-                <a:ea typeface="Calibri"/>
-              </a:rPr>
-              <a:t>Heading</a:t>
-            </a:r>
-            <a:endParaRPr kumimoji="0" lang="en-US" sz="1733" b="0" i="0" u="none" strike="noStrike" kern="1200" cap="none" spc="0" normalizeH="0" baseline="0" noProof="0" dirty="0">
-              <a:ln>
-                <a:noFill/>
-              </a:ln>
-              <a:solidFill>
-                <a:srgbClr val="000000"/>
-              </a:solidFill>
-              <a:effectLst/>
-              <a:uLnTx/>
-              <a:uFillTx/>
-              <a:latin typeface="Arial"/>
-              <a:ea typeface="+mn-ea"/>
-              <a:cs typeface="+mn-cs"/>
-            </a:endParaRPr>
-          </a:p>
-        </p:txBody>
-      </p:sp>
-      <p:sp>
-        <p:nvSpPr>
-          <p:cNvPr id="200" name="Text 6">
-            <a:extLst>
-              <a:ext uri="{FF2B5EF4-FFF2-40B4-BE49-F238E27FC236}">
-                <a16:creationId xmlns:a16="http://schemas.microsoft.com/office/drawing/2014/main" id="{C2FD3EE1-9CA4-1E58-4783-B1EE0963F7DF}"/>
-              </a:ext>
-            </a:extLst>
-          </p:cNvPr>
-          <p:cNvSpPr/>
-          <p:nvPr/>
-        </p:nvSpPr>
-        <p:spPr>
-          <a:xfrm>
-            <a:off x="341520" y="1468321"/>
-            <a:ext cx="11423520" cy="1825508"/>
-          </a:xfrm>
-          <a:prstGeom prst="rect">
-            <a:avLst/>
-          </a:prstGeom>
-          <a:noFill/>
-          <a:ln w="0">
-            <a:noFill/>
-          </a:ln>
-        </p:spPr>
-        <p:style>
-          <a:lnRef idx="0">
-            <a:scrgbClr r="0" g="0" b="0"/>
-          </a:lnRef>
-          <a:fillRef idx="0">
-            <a:scrgbClr r="0" g="0" b="0"/>
-          </a:fillRef>
-          <a:effectRef idx="0">
-            <a:scrgbClr r="0" g="0" b="0"/>
-          </a:effectRef>
-          <a:fontRef idx="minor"/>
-        </p:style>
-        <p:txBody>
-          <a:bodyPr lIns="120000" tIns="60000" rIns="120000" bIns="60000" anchor="t">
-            <a:noAutofit/>
-          </a:bodyPr>
-          <a:lstStyle/>
-          <a:p>
-            <a:pPr marL="228594" marR="0" lvl="0" indent="-228594" algn="l" defTabSz="1219170" rtl="0" eaLnBrk="1" fontAlgn="auto" latinLnBrk="0" hangingPunct="1">
-              <a:lnSpc>
-                <a:spcPct val="100000"/>
-              </a:lnSpc>
-              <a:spcBef>
-                <a:spcPts val="0"/>
-              </a:spcBef>
-              <a:spcAft>
-                <a:spcPts val="665"/>
-              </a:spcAft>
-              <a:buClr>
-                <a:srgbClr val="1A1A2E"/>
-              </a:buClr>
-              <a:buSzTx/>
-              <a:buFont typeface="Arial" panose="020B0604020202020204" pitchFamily="34" charset="0"/>
-              <a:buChar char="•"/>
-              <a:tabLst/>
-              <a:defRPr/>
-            </a:pPr>
-            <a:r>
-              <a:rPr kumimoji="0" lang="en-US" sz="1600" b="1" i="0" u="none" strike="noStrike" kern="1200" cap="none" spc="0" normalizeH="0" baseline="0" noProof="0" dirty="0">
-                <a:ln>
-                  <a:noFill/>
-                </a:ln>
-                <a:solidFill>
-                  <a:srgbClr val="1A1A2E"/>
-                </a:solidFill>
-                <a:effectLst/>
-                <a:uLnTx/>
-                <a:uFillTx/>
-                <a:latin typeface="Calibri" panose="020F0502020204030204"/>
-                <a:ea typeface="Calibri"/>
-                <a:cs typeface="+mn-cs"/>
-              </a:rPr>
-              <a:t>Number of Encoder Blocks: Keep it Simple</a:t>
-            </a:r>
-          </a:p>
-          <a:p>
-            <a:pPr marL="228594" marR="0" lvl="0" indent="-228594" algn="l" defTabSz="1219170" rtl="0" eaLnBrk="1" fontAlgn="auto" latinLnBrk="0" hangingPunct="1">
-              <a:lnSpc>
-                <a:spcPct val="100000"/>
-              </a:lnSpc>
-              <a:spcBef>
-                <a:spcPts val="0"/>
-              </a:spcBef>
-              <a:spcAft>
-                <a:spcPts val="665"/>
-              </a:spcAft>
-              <a:buClr>
-                <a:srgbClr val="1A1A2E"/>
-              </a:buClr>
-              <a:buSzTx/>
-              <a:buFont typeface="Arial" panose="020B0604020202020204" pitchFamily="34" charset="0"/>
-              <a:buChar char="•"/>
-              <a:tabLst/>
-              <a:defRPr/>
-            </a:pPr>
-            <a:r>
-              <a:rPr kumimoji="0" lang="en-US" sz="1600" b="1" i="0" u="none" strike="noStrike" kern="1200" cap="none" spc="0" normalizeH="0" baseline="0" noProof="0" dirty="0" err="1">
-                <a:ln>
-                  <a:noFill/>
-                </a:ln>
-                <a:solidFill>
-                  <a:srgbClr val="000000"/>
-                </a:solidFill>
-                <a:effectLst/>
-                <a:uLnTx/>
-                <a:uFillTx/>
-                <a:latin typeface="Calibri" panose="020F0502020204030204"/>
-                <a:ea typeface="+mn-ea"/>
-                <a:cs typeface="+mn-cs"/>
-              </a:rPr>
-              <a:t>Head_Size</a:t>
-            </a:r>
-            <a:r>
-              <a:rPr kumimoji="0" lang="en-US" sz="1600" b="1" i="0" u="none" strike="noStrike" kern="1200" cap="none" spc="0" normalizeH="0" baseline="0" noProof="0" dirty="0">
-                <a:ln>
-                  <a:noFill/>
-                </a:ln>
-                <a:solidFill>
-                  <a:srgbClr val="000000"/>
-                </a:solidFill>
-                <a:effectLst/>
-                <a:uLnTx/>
-                <a:uFillTx/>
-                <a:latin typeface="Calibri" panose="020F0502020204030204"/>
-                <a:ea typeface="+mn-ea"/>
-                <a:cs typeface="+mn-cs"/>
-              </a:rPr>
-              <a:t>: Number of days remembered per </a:t>
-            </a:r>
-          </a:p>
-          <a:p>
-            <a:pPr marL="228594" marR="0" lvl="0" indent="-228594" algn="l" defTabSz="1219170" rtl="0" eaLnBrk="1" fontAlgn="auto" latinLnBrk="0" hangingPunct="1">
-              <a:lnSpc>
-                <a:spcPct val="100000"/>
-              </a:lnSpc>
-              <a:spcBef>
-                <a:spcPts val="0"/>
-              </a:spcBef>
-              <a:spcAft>
-                <a:spcPts val="665"/>
-              </a:spcAft>
-              <a:buClr>
-                <a:srgbClr val="1A1A2E"/>
-              </a:buClr>
-              <a:buSzTx/>
-              <a:buFont typeface="Arial" panose="020B0604020202020204" pitchFamily="34" charset="0"/>
-              <a:buChar char="•"/>
-              <a:tabLst/>
-              <a:defRPr/>
-            </a:pPr>
-            <a:r>
-              <a:rPr kumimoji="0" lang="en-US" sz="1600" b="1" i="0" u="none" strike="noStrike" kern="1200" cap="none" spc="0" normalizeH="0" baseline="0" noProof="0" dirty="0">
-                <a:ln>
-                  <a:noFill/>
-                </a:ln>
-                <a:solidFill>
-                  <a:srgbClr val="000000"/>
-                </a:solidFill>
-                <a:effectLst/>
-                <a:uLnTx/>
-                <a:uFillTx/>
-                <a:latin typeface="Calibri" panose="020F0502020204030204"/>
-                <a:ea typeface="+mn-ea"/>
-                <a:cs typeface="+mn-cs"/>
-              </a:rPr>
-              <a:t>Dropout percentage: Needs considerable dropout layers</a:t>
-            </a:r>
-          </a:p>
-          <a:p>
-            <a:pPr marL="228594" marR="0" lvl="0" indent="-228594" algn="l" defTabSz="1219170" rtl="0" eaLnBrk="1" fontAlgn="auto" latinLnBrk="0" hangingPunct="1">
-              <a:lnSpc>
-                <a:spcPct val="100000"/>
-              </a:lnSpc>
-              <a:spcBef>
-                <a:spcPts val="0"/>
-              </a:spcBef>
-              <a:spcAft>
-                <a:spcPts val="665"/>
-              </a:spcAft>
-              <a:buClr>
-                <a:srgbClr val="1A1A2E"/>
-              </a:buClr>
-              <a:buSzTx/>
-              <a:buFont typeface="Arial" panose="020B0604020202020204" pitchFamily="34" charset="0"/>
-              <a:buChar char="•"/>
-              <a:tabLst/>
-              <a:defRPr/>
-            </a:pPr>
-            <a:r>
-              <a:rPr kumimoji="0" lang="en-US" sz="1600" b="1" i="0" u="none" strike="noStrike" kern="1200" cap="none" spc="0" normalizeH="0" baseline="0" noProof="0" dirty="0">
-                <a:ln>
-                  <a:noFill/>
-                </a:ln>
-                <a:solidFill>
-                  <a:srgbClr val="000000"/>
-                </a:solidFill>
-                <a:effectLst/>
-                <a:uLnTx/>
-                <a:uFillTx/>
-                <a:latin typeface="Calibri" panose="020F0502020204030204"/>
-                <a:ea typeface="+mn-ea"/>
-                <a:cs typeface="+mn-cs"/>
-              </a:rPr>
-              <a:t>Feed-Forward Dimension</a:t>
-            </a:r>
-            <a:r>
-              <a:rPr lang="en-US" sz="1600" b="1" dirty="0">
-                <a:solidFill>
-                  <a:srgbClr val="000000"/>
-                </a:solidFill>
-                <a:latin typeface="Calibri" panose="020F0502020204030204"/>
-              </a:rPr>
-              <a:t>:</a:t>
-            </a:r>
-            <a:endParaRPr kumimoji="0" lang="en-US" sz="1600" b="1" i="0" u="none" strike="noStrike" kern="1200" cap="none" spc="0" normalizeH="0" baseline="0" noProof="0" dirty="0">
-              <a:ln>
-                <a:noFill/>
-              </a:ln>
-              <a:solidFill>
-                <a:srgbClr val="000000"/>
-              </a:solidFill>
-              <a:effectLst/>
-              <a:uLnTx/>
-              <a:uFillTx/>
-              <a:latin typeface="Calibri" panose="020F0502020204030204"/>
-              <a:ea typeface="+mn-ea"/>
-              <a:cs typeface="+mn-cs"/>
-            </a:endParaRPr>
-          </a:p>
-          <a:p>
-            <a:pPr marL="228594" marR="0" lvl="0" indent="-228594" algn="l" defTabSz="1219170" rtl="0" eaLnBrk="1" fontAlgn="auto" latinLnBrk="0" hangingPunct="1">
-              <a:lnSpc>
-                <a:spcPct val="100000"/>
-              </a:lnSpc>
-              <a:spcBef>
-                <a:spcPts val="0"/>
-              </a:spcBef>
-              <a:spcAft>
-                <a:spcPts val="665"/>
-              </a:spcAft>
-              <a:buClr>
-                <a:srgbClr val="1A1A2E"/>
-              </a:buClr>
-              <a:buSzTx/>
-              <a:buFont typeface="Arial" panose="020B0604020202020204" pitchFamily="34" charset="0"/>
-              <a:buChar char="•"/>
-              <a:tabLst/>
-              <a:defRPr/>
-            </a:pPr>
-            <a:r>
-              <a:rPr kumimoji="0" lang="en-US" sz="1600" b="1" i="0" u="none" strike="noStrike" kern="1200" cap="none" spc="0" normalizeH="0" baseline="0" noProof="0" dirty="0">
-                <a:ln>
-                  <a:noFill/>
-                </a:ln>
-                <a:solidFill>
-                  <a:srgbClr val="000000"/>
-                </a:solidFill>
-                <a:effectLst/>
-                <a:uLnTx/>
-                <a:uFillTx/>
-                <a:latin typeface="Calibri" panose="020F0502020204030204"/>
-                <a:ea typeface="+mn-ea"/>
-                <a:cs typeface="+mn-cs"/>
-              </a:rPr>
-              <a:t>Epochs: Never needs more than a few, but they run slow</a:t>
-            </a:r>
           </a:p>
         </p:txBody>
       </p:sp>
@@ -25075,6 +24751,722 @@
               <a:ea typeface="+mn-ea"/>
               <a:cs typeface="+mn-cs"/>
             </a:endParaRPr>
+          </a:p>
+        </p:txBody>
+      </p:sp>
+      <p:sp>
+        <p:nvSpPr>
+          <p:cNvPr id="3" name="Rectangle: Rounded Corners 2">
+            <a:extLst>
+              <a:ext uri="{FF2B5EF4-FFF2-40B4-BE49-F238E27FC236}">
+                <a16:creationId xmlns:a16="http://schemas.microsoft.com/office/drawing/2014/main" id="{D990C7E5-9699-F83F-ACBF-67E390CA5E88}"/>
+              </a:ext>
+            </a:extLst>
+          </p:cNvPr>
+          <p:cNvSpPr/>
+          <p:nvPr/>
+        </p:nvSpPr>
+        <p:spPr>
+          <a:xfrm>
+            <a:off x="203202" y="1104348"/>
+            <a:ext cx="2252870" cy="5031409"/>
+          </a:xfrm>
+          <a:prstGeom prst="roundRect">
+            <a:avLst/>
+          </a:prstGeom>
+        </p:spPr>
+        <p:style>
+          <a:lnRef idx="2">
+            <a:schemeClr val="accent5">
+              <a:shade val="15000"/>
+            </a:schemeClr>
+          </a:lnRef>
+          <a:fillRef idx="1">
+            <a:schemeClr val="accent5"/>
+          </a:fillRef>
+          <a:effectRef idx="0">
+            <a:schemeClr val="accent5"/>
+          </a:effectRef>
+          <a:fontRef idx="minor">
+            <a:schemeClr val="lt1"/>
+          </a:fontRef>
+        </p:style>
+        <p:txBody>
+          <a:bodyPr rtlCol="0" anchor="ctr"/>
+          <a:lstStyle/>
+          <a:p>
+            <a:pPr algn="ctr"/>
+            <a:endParaRPr lang="en-US"/>
+          </a:p>
+        </p:txBody>
+      </p:sp>
+      <p:sp>
+        <p:nvSpPr>
+          <p:cNvPr id="5" name="Rectangle: Rounded Corners 4">
+            <a:extLst>
+              <a:ext uri="{FF2B5EF4-FFF2-40B4-BE49-F238E27FC236}">
+                <a16:creationId xmlns:a16="http://schemas.microsoft.com/office/drawing/2014/main" id="{7AD8442A-3D26-B554-A0F6-7C4059DCA138}"/>
+              </a:ext>
+            </a:extLst>
+          </p:cNvPr>
+          <p:cNvSpPr/>
+          <p:nvPr/>
+        </p:nvSpPr>
+        <p:spPr>
+          <a:xfrm>
+            <a:off x="2615102" y="1104348"/>
+            <a:ext cx="2252870" cy="5031409"/>
+          </a:xfrm>
+          <a:prstGeom prst="roundRect">
+            <a:avLst/>
+          </a:prstGeom>
+        </p:spPr>
+        <p:style>
+          <a:lnRef idx="2">
+            <a:schemeClr val="accent5">
+              <a:shade val="15000"/>
+            </a:schemeClr>
+          </a:lnRef>
+          <a:fillRef idx="1">
+            <a:schemeClr val="accent5"/>
+          </a:fillRef>
+          <a:effectRef idx="0">
+            <a:schemeClr val="accent5"/>
+          </a:effectRef>
+          <a:fontRef idx="minor">
+            <a:schemeClr val="lt1"/>
+          </a:fontRef>
+        </p:style>
+        <p:txBody>
+          <a:bodyPr rtlCol="0" anchor="ctr"/>
+          <a:lstStyle/>
+          <a:p>
+            <a:pPr algn="ctr"/>
+            <a:endParaRPr lang="en-US"/>
+          </a:p>
+        </p:txBody>
+      </p:sp>
+      <p:sp>
+        <p:nvSpPr>
+          <p:cNvPr id="6" name="Rectangle: Rounded Corners 5">
+            <a:extLst>
+              <a:ext uri="{FF2B5EF4-FFF2-40B4-BE49-F238E27FC236}">
+                <a16:creationId xmlns:a16="http://schemas.microsoft.com/office/drawing/2014/main" id="{70374694-3C17-D1F8-90F7-5DEE176D56D3}"/>
+              </a:ext>
+            </a:extLst>
+          </p:cNvPr>
+          <p:cNvSpPr/>
+          <p:nvPr/>
+        </p:nvSpPr>
+        <p:spPr>
+          <a:xfrm>
+            <a:off x="5027002" y="1103886"/>
+            <a:ext cx="2252870" cy="5031409"/>
+          </a:xfrm>
+          <a:prstGeom prst="roundRect">
+            <a:avLst/>
+          </a:prstGeom>
+        </p:spPr>
+        <p:style>
+          <a:lnRef idx="2">
+            <a:schemeClr val="accent5">
+              <a:shade val="15000"/>
+            </a:schemeClr>
+          </a:lnRef>
+          <a:fillRef idx="1">
+            <a:schemeClr val="accent5"/>
+          </a:fillRef>
+          <a:effectRef idx="0">
+            <a:schemeClr val="accent5"/>
+          </a:effectRef>
+          <a:fontRef idx="minor">
+            <a:schemeClr val="lt1"/>
+          </a:fontRef>
+        </p:style>
+        <p:txBody>
+          <a:bodyPr rtlCol="0" anchor="ctr"/>
+          <a:lstStyle/>
+          <a:p>
+            <a:pPr algn="ctr"/>
+            <a:endParaRPr lang="en-US"/>
+          </a:p>
+        </p:txBody>
+      </p:sp>
+      <p:sp>
+        <p:nvSpPr>
+          <p:cNvPr id="7" name="Rectangle: Rounded Corners 6">
+            <a:extLst>
+              <a:ext uri="{FF2B5EF4-FFF2-40B4-BE49-F238E27FC236}">
+                <a16:creationId xmlns:a16="http://schemas.microsoft.com/office/drawing/2014/main" id="{E99ECD44-3C1C-B389-638C-AB51A9A0379C}"/>
+              </a:ext>
+            </a:extLst>
+          </p:cNvPr>
+          <p:cNvSpPr/>
+          <p:nvPr/>
+        </p:nvSpPr>
+        <p:spPr>
+          <a:xfrm>
+            <a:off x="7438902" y="1104348"/>
+            <a:ext cx="2252870" cy="5031409"/>
+          </a:xfrm>
+          <a:prstGeom prst="roundRect">
+            <a:avLst/>
+          </a:prstGeom>
+        </p:spPr>
+        <p:style>
+          <a:lnRef idx="2">
+            <a:schemeClr val="accent5">
+              <a:shade val="15000"/>
+            </a:schemeClr>
+          </a:lnRef>
+          <a:fillRef idx="1">
+            <a:schemeClr val="accent5"/>
+          </a:fillRef>
+          <a:effectRef idx="0">
+            <a:schemeClr val="accent5"/>
+          </a:effectRef>
+          <a:fontRef idx="minor">
+            <a:schemeClr val="lt1"/>
+          </a:fontRef>
+        </p:style>
+        <p:txBody>
+          <a:bodyPr rtlCol="0" anchor="ctr"/>
+          <a:lstStyle/>
+          <a:p>
+            <a:pPr algn="ctr"/>
+            <a:endParaRPr lang="en-US"/>
+          </a:p>
+        </p:txBody>
+      </p:sp>
+      <p:sp>
+        <p:nvSpPr>
+          <p:cNvPr id="8" name="Rectangle: Rounded Corners 7">
+            <a:extLst>
+              <a:ext uri="{FF2B5EF4-FFF2-40B4-BE49-F238E27FC236}">
+                <a16:creationId xmlns:a16="http://schemas.microsoft.com/office/drawing/2014/main" id="{78B3DC4E-CC44-E3C9-0E1C-71455D548B75}"/>
+              </a:ext>
+            </a:extLst>
+          </p:cNvPr>
+          <p:cNvSpPr/>
+          <p:nvPr/>
+        </p:nvSpPr>
+        <p:spPr>
+          <a:xfrm>
+            <a:off x="9850802" y="1104348"/>
+            <a:ext cx="2252870" cy="5031409"/>
+          </a:xfrm>
+          <a:prstGeom prst="roundRect">
+            <a:avLst/>
+          </a:prstGeom>
+        </p:spPr>
+        <p:style>
+          <a:lnRef idx="2">
+            <a:schemeClr val="accent5">
+              <a:shade val="15000"/>
+            </a:schemeClr>
+          </a:lnRef>
+          <a:fillRef idx="1">
+            <a:schemeClr val="accent5"/>
+          </a:fillRef>
+          <a:effectRef idx="0">
+            <a:schemeClr val="accent5"/>
+          </a:effectRef>
+          <a:fontRef idx="minor">
+            <a:schemeClr val="lt1"/>
+          </a:fontRef>
+        </p:style>
+        <p:txBody>
+          <a:bodyPr rtlCol="0" anchor="ctr"/>
+          <a:lstStyle/>
+          <a:p>
+            <a:pPr algn="ctr"/>
+            <a:endParaRPr lang="en-US"/>
+          </a:p>
+        </p:txBody>
+      </p:sp>
+      <p:sp>
+        <p:nvSpPr>
+          <p:cNvPr id="9" name="TextBox 8">
+            <a:extLst>
+              <a:ext uri="{FF2B5EF4-FFF2-40B4-BE49-F238E27FC236}">
+                <a16:creationId xmlns:a16="http://schemas.microsoft.com/office/drawing/2014/main" id="{9F79EE86-C996-2866-5922-EBA76C965639}"/>
+              </a:ext>
+            </a:extLst>
+          </p:cNvPr>
+          <p:cNvSpPr txBox="1"/>
+          <p:nvPr/>
+        </p:nvSpPr>
+        <p:spPr>
+          <a:xfrm>
+            <a:off x="468243" y="1285461"/>
+            <a:ext cx="1718366" cy="369332"/>
+          </a:xfrm>
+          <a:prstGeom prst="rect">
+            <a:avLst/>
+          </a:prstGeom>
+          <a:noFill/>
+        </p:spPr>
+        <p:txBody>
+          <a:bodyPr wrap="square" rtlCol="0">
+            <a:spAutoFit/>
+          </a:bodyPr>
+          <a:lstStyle/>
+          <a:p>
+            <a:pPr algn="ctr"/>
+            <a:r>
+              <a:rPr lang="en-US" b="1" dirty="0"/>
+              <a:t>Block Count</a:t>
+            </a:r>
+          </a:p>
+        </p:txBody>
+      </p:sp>
+      <p:sp>
+        <p:nvSpPr>
+          <p:cNvPr id="10" name="TextBox 9">
+            <a:extLst>
+              <a:ext uri="{FF2B5EF4-FFF2-40B4-BE49-F238E27FC236}">
+                <a16:creationId xmlns:a16="http://schemas.microsoft.com/office/drawing/2014/main" id="{661B4FB0-5E57-06F0-D6AF-AE54157F4154}"/>
+              </a:ext>
+            </a:extLst>
+          </p:cNvPr>
+          <p:cNvSpPr txBox="1"/>
+          <p:nvPr/>
+        </p:nvSpPr>
+        <p:spPr>
+          <a:xfrm>
+            <a:off x="2873513" y="1285461"/>
+            <a:ext cx="1718366" cy="369332"/>
+          </a:xfrm>
+          <a:prstGeom prst="rect">
+            <a:avLst/>
+          </a:prstGeom>
+          <a:noFill/>
+        </p:spPr>
+        <p:txBody>
+          <a:bodyPr wrap="square" rtlCol="0">
+            <a:spAutoFit/>
+          </a:bodyPr>
+          <a:lstStyle/>
+          <a:p>
+            <a:pPr algn="ctr"/>
+            <a:r>
+              <a:rPr lang="en-US" b="1" dirty="0"/>
+              <a:t>Head Size</a:t>
+            </a:r>
+          </a:p>
+        </p:txBody>
+      </p:sp>
+      <p:sp>
+        <p:nvSpPr>
+          <p:cNvPr id="11" name="TextBox 10">
+            <a:extLst>
+              <a:ext uri="{FF2B5EF4-FFF2-40B4-BE49-F238E27FC236}">
+                <a16:creationId xmlns:a16="http://schemas.microsoft.com/office/drawing/2014/main" id="{7DAF1700-BCBA-B727-50AB-3CD9D4A4C84B}"/>
+              </a:ext>
+            </a:extLst>
+          </p:cNvPr>
+          <p:cNvSpPr txBox="1"/>
+          <p:nvPr/>
+        </p:nvSpPr>
+        <p:spPr>
+          <a:xfrm>
+            <a:off x="5273057" y="1146961"/>
+            <a:ext cx="1718366" cy="646331"/>
+          </a:xfrm>
+          <a:prstGeom prst="rect">
+            <a:avLst/>
+          </a:prstGeom>
+          <a:noFill/>
+        </p:spPr>
+        <p:txBody>
+          <a:bodyPr wrap="square" rtlCol="0">
+            <a:spAutoFit/>
+          </a:bodyPr>
+          <a:lstStyle/>
+          <a:p>
+            <a:pPr algn="ctr"/>
+            <a:r>
+              <a:rPr lang="en-US" b="1" dirty="0"/>
+              <a:t>Dropout / Masking Layers</a:t>
+            </a:r>
+          </a:p>
+        </p:txBody>
+      </p:sp>
+      <p:sp>
+        <p:nvSpPr>
+          <p:cNvPr id="12" name="TextBox 11">
+            <a:extLst>
+              <a:ext uri="{FF2B5EF4-FFF2-40B4-BE49-F238E27FC236}">
+                <a16:creationId xmlns:a16="http://schemas.microsoft.com/office/drawing/2014/main" id="{AE425666-23A7-D9B8-CCEA-BECDBA950510}"/>
+              </a:ext>
+            </a:extLst>
+          </p:cNvPr>
+          <p:cNvSpPr txBox="1"/>
+          <p:nvPr/>
+        </p:nvSpPr>
+        <p:spPr>
+          <a:xfrm>
+            <a:off x="7706154" y="1285460"/>
+            <a:ext cx="1718366" cy="369332"/>
+          </a:xfrm>
+          <a:prstGeom prst="rect">
+            <a:avLst/>
+          </a:prstGeom>
+          <a:noFill/>
+        </p:spPr>
+        <p:txBody>
+          <a:bodyPr wrap="square" rtlCol="0">
+            <a:spAutoFit/>
+          </a:bodyPr>
+          <a:lstStyle/>
+          <a:p>
+            <a:pPr algn="ctr"/>
+            <a:r>
+              <a:rPr lang="en-US" b="1" dirty="0"/>
+              <a:t>FFN Dimension</a:t>
+            </a:r>
+          </a:p>
+        </p:txBody>
+      </p:sp>
+      <p:sp>
+        <p:nvSpPr>
+          <p:cNvPr id="13" name="TextBox 12">
+            <a:extLst>
+              <a:ext uri="{FF2B5EF4-FFF2-40B4-BE49-F238E27FC236}">
+                <a16:creationId xmlns:a16="http://schemas.microsoft.com/office/drawing/2014/main" id="{7845E1D3-619C-D6FD-AB85-3A9B9063F121}"/>
+              </a:ext>
+            </a:extLst>
+          </p:cNvPr>
+          <p:cNvSpPr txBox="1"/>
+          <p:nvPr/>
+        </p:nvSpPr>
+        <p:spPr>
+          <a:xfrm>
+            <a:off x="10118054" y="1283250"/>
+            <a:ext cx="1718366" cy="369332"/>
+          </a:xfrm>
+          <a:prstGeom prst="rect">
+            <a:avLst/>
+          </a:prstGeom>
+          <a:noFill/>
+        </p:spPr>
+        <p:txBody>
+          <a:bodyPr wrap="square" rtlCol="0">
+            <a:spAutoFit/>
+          </a:bodyPr>
+          <a:lstStyle/>
+          <a:p>
+            <a:pPr algn="ctr"/>
+            <a:r>
+              <a:rPr lang="en-US" b="1" dirty="0"/>
+              <a:t># Epochs</a:t>
+            </a:r>
+          </a:p>
+        </p:txBody>
+      </p:sp>
+      <p:sp>
+        <p:nvSpPr>
+          <p:cNvPr id="14" name="TextBox 13">
+            <a:extLst>
+              <a:ext uri="{FF2B5EF4-FFF2-40B4-BE49-F238E27FC236}">
+                <a16:creationId xmlns:a16="http://schemas.microsoft.com/office/drawing/2014/main" id="{A54A8004-2520-0A29-5D0B-4EC290D42F4B}"/>
+              </a:ext>
+            </a:extLst>
+          </p:cNvPr>
+          <p:cNvSpPr txBox="1"/>
+          <p:nvPr/>
+        </p:nvSpPr>
+        <p:spPr>
+          <a:xfrm>
+            <a:off x="329184" y="2195443"/>
+            <a:ext cx="1959025" cy="2292935"/>
+          </a:xfrm>
+          <a:prstGeom prst="rect">
+            <a:avLst/>
+          </a:prstGeom>
+          <a:noFill/>
+        </p:spPr>
+        <p:txBody>
+          <a:bodyPr wrap="square" rtlCol="0">
+            <a:spAutoFit/>
+          </a:bodyPr>
+          <a:lstStyle/>
+          <a:p>
+            <a:pPr marL="285750" indent="-285750">
+              <a:buFont typeface="Arial" panose="020B0604020202020204" pitchFamily="34" charset="0"/>
+              <a:buChar char="•"/>
+            </a:pPr>
+            <a:r>
+              <a:rPr lang="en-US" sz="1300" dirty="0"/>
+              <a:t>Keep number of blocks low (2-4)</a:t>
+            </a:r>
+          </a:p>
+          <a:p>
+            <a:r>
+              <a:rPr lang="en-US" sz="1300" dirty="0"/>
+              <a:t> </a:t>
+            </a:r>
+          </a:p>
+          <a:p>
+            <a:pPr marL="285750" indent="-285750">
+              <a:buFont typeface="Arial" panose="020B0604020202020204" pitchFamily="34" charset="0"/>
+              <a:buChar char="•"/>
+            </a:pPr>
+            <a:r>
+              <a:rPr lang="en-US" sz="1300" dirty="0"/>
+              <a:t>Why: Each block will allow the transformer to memorize something different about the data. This can quickly lead to overfitting with such a simple dataset.</a:t>
+            </a:r>
+          </a:p>
+        </p:txBody>
+      </p:sp>
+      <p:sp>
+        <p:nvSpPr>
+          <p:cNvPr id="15" name="TextBox 14">
+            <a:extLst>
+              <a:ext uri="{FF2B5EF4-FFF2-40B4-BE49-F238E27FC236}">
+                <a16:creationId xmlns:a16="http://schemas.microsoft.com/office/drawing/2014/main" id="{AE4762ED-8923-849D-40A8-1C19397B92BE}"/>
+              </a:ext>
+            </a:extLst>
+          </p:cNvPr>
+          <p:cNvSpPr txBox="1"/>
+          <p:nvPr/>
+        </p:nvSpPr>
+        <p:spPr>
+          <a:xfrm>
+            <a:off x="2776334" y="2184399"/>
+            <a:ext cx="2016536" cy="2693045"/>
+          </a:xfrm>
+          <a:prstGeom prst="rect">
+            <a:avLst/>
+          </a:prstGeom>
+          <a:noFill/>
+        </p:spPr>
+        <p:txBody>
+          <a:bodyPr wrap="square" rtlCol="0">
+            <a:spAutoFit/>
+          </a:bodyPr>
+          <a:lstStyle/>
+          <a:p>
+            <a:pPr marL="285750" indent="-285750">
+              <a:buFont typeface="Arial" panose="020B0604020202020204" pitchFamily="34" charset="0"/>
+              <a:buChar char="•"/>
+            </a:pPr>
+            <a:r>
+              <a:rPr lang="en-US" sz="1300" dirty="0"/>
+              <a:t>Set a sequence length of ~21. </a:t>
+            </a:r>
+          </a:p>
+          <a:p>
+            <a:r>
+              <a:rPr lang="en-US" sz="1300" dirty="0"/>
+              <a:t> </a:t>
+            </a:r>
+          </a:p>
+          <a:p>
+            <a:pPr marL="285750" indent="-285750">
+              <a:buFont typeface="Arial" panose="020B0604020202020204" pitchFamily="34" charset="0"/>
+              <a:buChar char="•"/>
+            </a:pPr>
+            <a:r>
+              <a:rPr lang="en-US" sz="1300" dirty="0"/>
+              <a:t>Why: The sequence length determines how many rows (data) the model will keep in its memory when running the Attention Layer. The variable with the longest backward-looking period is 20 days.</a:t>
+            </a:r>
+          </a:p>
+        </p:txBody>
+      </p:sp>
+      <p:sp>
+        <p:nvSpPr>
+          <p:cNvPr id="16" name="TextBox 15">
+            <a:extLst>
+              <a:ext uri="{FF2B5EF4-FFF2-40B4-BE49-F238E27FC236}">
+                <a16:creationId xmlns:a16="http://schemas.microsoft.com/office/drawing/2014/main" id="{1FF31B26-E519-B387-9D57-5E9ABEE0CC54}"/>
+              </a:ext>
+            </a:extLst>
+          </p:cNvPr>
+          <p:cNvSpPr txBox="1"/>
+          <p:nvPr/>
+        </p:nvSpPr>
+        <p:spPr>
+          <a:xfrm>
+            <a:off x="5146020" y="2184398"/>
+            <a:ext cx="2100723" cy="3093154"/>
+          </a:xfrm>
+          <a:prstGeom prst="rect">
+            <a:avLst/>
+          </a:prstGeom>
+          <a:noFill/>
+        </p:spPr>
+        <p:txBody>
+          <a:bodyPr wrap="square" rtlCol="0">
+            <a:spAutoFit/>
+          </a:bodyPr>
+          <a:lstStyle/>
+          <a:p>
+            <a:pPr marL="285750" indent="-285750">
+              <a:buFont typeface="Arial" panose="020B0604020202020204" pitchFamily="34" charset="0"/>
+              <a:buChar char="•"/>
+            </a:pPr>
+            <a:r>
+              <a:rPr lang="en-US" sz="1300" dirty="0"/>
+              <a:t>Randomly deactivating weights while training the model to avoid overfitting.</a:t>
+            </a:r>
+          </a:p>
+          <a:p>
+            <a:r>
+              <a:rPr lang="en-US" sz="1300" dirty="0"/>
+              <a:t> </a:t>
+            </a:r>
+          </a:p>
+          <a:p>
+            <a:pPr marL="285750" indent="-285750">
+              <a:buFont typeface="Arial" panose="020B0604020202020204" pitchFamily="34" charset="0"/>
+              <a:buChar char="•"/>
+            </a:pPr>
+            <a:r>
+              <a:rPr lang="en-US" sz="1300" b="1" dirty="0"/>
+              <a:t>Why: </a:t>
+            </a:r>
+            <a:r>
+              <a:rPr lang="en-US" sz="1300" dirty="0"/>
+              <a:t>Transformers are the most complex mainstream models due to their ability to memorize data so well. This can quickly lead to overfitting, so forcing it to not rely on patterns when training is extremely important.</a:t>
+            </a:r>
+            <a:endParaRPr lang="en-US" sz="1300" b="1" dirty="0"/>
+          </a:p>
+        </p:txBody>
+      </p:sp>
+      <p:sp>
+        <p:nvSpPr>
+          <p:cNvPr id="17" name="TextBox 16">
+            <a:extLst>
+              <a:ext uri="{FF2B5EF4-FFF2-40B4-BE49-F238E27FC236}">
+                <a16:creationId xmlns:a16="http://schemas.microsoft.com/office/drawing/2014/main" id="{5F442D0E-B876-F20A-5DF8-FE8D19522BAE}"/>
+              </a:ext>
+            </a:extLst>
+          </p:cNvPr>
+          <p:cNvSpPr txBox="1"/>
+          <p:nvPr/>
+        </p:nvSpPr>
+        <p:spPr>
+          <a:xfrm>
+            <a:off x="7471776" y="2171144"/>
+            <a:ext cx="2144653" cy="2292935"/>
+          </a:xfrm>
+          <a:prstGeom prst="rect">
+            <a:avLst/>
+          </a:prstGeom>
+          <a:noFill/>
+        </p:spPr>
+        <p:txBody>
+          <a:bodyPr wrap="square" rtlCol="0">
+            <a:spAutoFit/>
+          </a:bodyPr>
+          <a:lstStyle/>
+          <a:p>
+            <a:pPr marL="285750" indent="-285750">
+              <a:buFont typeface="Arial" panose="020B0604020202020204" pitchFamily="34" charset="0"/>
+              <a:buChar char="•"/>
+            </a:pPr>
+            <a:r>
+              <a:rPr lang="en-US" sz="1300" dirty="0"/>
+              <a:t>Increasing dimensionality in transformer block before applying </a:t>
+            </a:r>
+            <a:r>
+              <a:rPr lang="en-US" sz="1300" dirty="0" err="1"/>
+              <a:t>ReLU</a:t>
+            </a:r>
+            <a:r>
+              <a:rPr lang="en-US" sz="1300" dirty="0"/>
+              <a:t>.</a:t>
+            </a:r>
+          </a:p>
+          <a:p>
+            <a:r>
+              <a:rPr lang="en-US" sz="1300" dirty="0"/>
+              <a:t> </a:t>
+            </a:r>
+          </a:p>
+          <a:p>
+            <a:pPr marL="285750" indent="-285750">
+              <a:buFont typeface="Arial" panose="020B0604020202020204" pitchFamily="34" charset="0"/>
+              <a:buChar char="•"/>
+            </a:pPr>
+            <a:r>
+              <a:rPr lang="en-US" sz="1300" b="1" dirty="0"/>
+              <a:t>Why: </a:t>
+            </a:r>
+            <a:r>
+              <a:rPr lang="en-US" sz="1300" dirty="0"/>
+              <a:t>Expanding the dimensions by a significant amount allows us to find greater non-linear relationships with the </a:t>
+            </a:r>
+            <a:r>
+              <a:rPr lang="en-US" sz="1300" dirty="0" err="1"/>
+              <a:t>ReLU</a:t>
+            </a:r>
+            <a:r>
+              <a:rPr lang="en-US" sz="1300" dirty="0"/>
+              <a:t> function.</a:t>
+            </a:r>
+            <a:endParaRPr lang="en-US" sz="1300" b="1" dirty="0"/>
+          </a:p>
+        </p:txBody>
+      </p:sp>
+      <p:sp>
+        <p:nvSpPr>
+          <p:cNvPr id="18" name="TextBox 17">
+            <a:extLst>
+              <a:ext uri="{FF2B5EF4-FFF2-40B4-BE49-F238E27FC236}">
+                <a16:creationId xmlns:a16="http://schemas.microsoft.com/office/drawing/2014/main" id="{2BA420E8-47C7-764C-CDD4-BFCD091717F2}"/>
+              </a:ext>
+            </a:extLst>
+          </p:cNvPr>
+          <p:cNvSpPr txBox="1"/>
+          <p:nvPr/>
+        </p:nvSpPr>
+        <p:spPr>
+          <a:xfrm>
+            <a:off x="9850802" y="2171143"/>
+            <a:ext cx="2221928" cy="2492990"/>
+          </a:xfrm>
+          <a:prstGeom prst="rect">
+            <a:avLst/>
+          </a:prstGeom>
+          <a:noFill/>
+        </p:spPr>
+        <p:txBody>
+          <a:bodyPr wrap="square" rtlCol="0">
+            <a:spAutoFit/>
+          </a:bodyPr>
+          <a:lstStyle/>
+          <a:p>
+            <a:pPr marL="285750" indent="-285750">
+              <a:buFont typeface="Arial" panose="020B0604020202020204" pitchFamily="34" charset="0"/>
+              <a:buChar char="•"/>
+            </a:pPr>
+            <a:r>
+              <a:rPr lang="en-US" sz="1300" dirty="0"/>
+              <a:t>High Epoch limit (100 to 200) with Early Stopping Callbacks.</a:t>
+            </a:r>
+          </a:p>
+          <a:p>
+            <a:r>
+              <a:rPr lang="en-US" sz="1300" dirty="0"/>
+              <a:t> </a:t>
+            </a:r>
+          </a:p>
+          <a:p>
+            <a:pPr marL="285750" indent="-285750">
+              <a:buFont typeface="Arial" panose="020B0604020202020204" pitchFamily="34" charset="0"/>
+              <a:buChar char="•"/>
+            </a:pPr>
+            <a:r>
+              <a:rPr lang="en-US" sz="1300" b="1" dirty="0"/>
+              <a:t>Why: </a:t>
+            </a:r>
+            <a:r>
+              <a:rPr lang="en-US" sz="1300" dirty="0"/>
+              <a:t>Transformers are computationally expensive and slow to learn. Setting a high epoch number with a callback allows us to maximize performance without overfitting.</a:t>
+            </a:r>
+            <a:endParaRPr lang="en-US" sz="1300" b="1" dirty="0"/>
           </a:p>
         </p:txBody>
       </p:sp>
@@ -25392,7 +25784,7 @@
             </p:custDataLst>
             <p:extLst>
               <p:ext uri="{D42A27DB-BD31-4B8C-83A1-F6EECF244321}">
-                <p14:modId xmlns:p14="http://schemas.microsoft.com/office/powerpoint/2010/main" val="728612292"/>
+                <p14:modId xmlns:p14="http://schemas.microsoft.com/office/powerpoint/2010/main" val="3870027332"/>
               </p:ext>
             </p:extLst>
           </p:nvPr>
@@ -28326,7 +28718,7 @@
                       <a:r>
                         <a:rPr lang="en-US" sz="1400" b="1" u="none" strike="noStrike" kern="1200" dirty="0">
                           <a:solidFill>
-                            <a:srgbClr val="000000"/>
+                            <a:srgbClr val="00A8CC"/>
                           </a:solidFill>
                           <a:effectLst/>
                           <a:uFillTx/>
@@ -28334,7 +28726,7 @@
                           <a:ea typeface="Calibri"/>
                           <a:cs typeface="+mn-cs"/>
                         </a:rPr>
-                        <a:t>0.1021 </a:t>
+                        <a:t>0.1034</a:t>
                       </a:r>
                     </a:p>
                   </a:txBody>
@@ -28396,7 +28788,7 @@
                       <a:r>
                         <a:rPr lang="en-US" sz="1400" b="1" u="none" strike="noStrike" kern="1200" dirty="0">
                           <a:solidFill>
-                            <a:srgbClr val="000000"/>
+                            <a:srgbClr val="00A8CC"/>
                           </a:solidFill>
                           <a:effectLst/>
                           <a:uFillTx/>
@@ -28404,7 +28796,7 @@
                           <a:ea typeface="Calibri"/>
                           <a:cs typeface="+mn-cs"/>
                         </a:rPr>
-                        <a:t>0.1506</a:t>
+                        <a:t>0.1503</a:t>
                       </a:r>
                     </a:p>
                   </a:txBody>
@@ -28466,7 +28858,7 @@
                       <a:r>
                         <a:rPr lang="en-US" sz="1400" b="1" u="none" strike="noStrike" kern="1200" dirty="0">
                           <a:solidFill>
-                            <a:srgbClr val="000000"/>
+                            <a:srgbClr val="00A8CC"/>
                           </a:solidFill>
                           <a:effectLst/>
                           <a:uFillTx/>
@@ -28474,7 +28866,7 @@
                           <a:ea typeface="Calibri"/>
                           <a:cs typeface="+mn-cs"/>
                         </a:rPr>
-                        <a:t>0.0383</a:t>
+                        <a:t>0.0425</a:t>
                       </a:r>
                     </a:p>
                   </a:txBody>
@@ -28533,14 +28925,19 @@
                           <a:tab pos="0" algn="l"/>
                         </a:tabLst>
                       </a:pPr>
-                      <a:endParaRPr lang="en-US" sz="1400" b="0" u="none" strike="noStrike" dirty="0">
-                        <a:solidFill>
-                          <a:srgbClr val="000000"/>
-                        </a:solidFill>
-                        <a:effectLst/>
-                        <a:uFillTx/>
-                        <a:latin typeface="Arial"/>
-                      </a:endParaRPr>
+                      <a:r>
+                        <a:rPr lang="en-US" sz="1400" b="1" u="none" strike="noStrike" kern="1200" dirty="0">
+                          <a:solidFill>
+                            <a:srgbClr val="00A8CC"/>
+                          </a:solidFill>
+                          <a:effectLst/>
+                          <a:uFillTx/>
+                          <a:latin typeface="Calibri"/>
+                          <a:ea typeface="Calibri"/>
+                          <a:cs typeface="+mn-cs"/>
+                        </a:rPr>
+                        <a:t>+0.0211</a:t>
+                      </a:r>
                     </a:p>
                   </a:txBody>
                   <a:tcPr marL="121920" marR="121920" marT="60960" marB="60960" anchor="ctr">

</xml_diff>